<commit_message>
Clarify MySQL 9.7 LTS wording
</commit_message>
<xml_diff>
--- a/outputs/MySQL9.7 and 26.7.pptx
+++ b/outputs/MySQL9.7 and 26.7.pptx
@@ -2,35 +2,130 @@
 <file path=ppt/presentation.xml><?xml version="1.0" encoding="utf-8"?>
 <p:presentation xmlns:p="http://schemas.openxmlformats.org/presentationml/2006/main">
   <p:sldMasterIdLst>
-    <p:sldMasterId xmlns:r="http://schemas.openxmlformats.org/officeDocument/2006/relationships" id="2147483648" r:id="Rf9d94cf3df164d84"/>
+    <p:sldMasterId xmlns:r="http://schemas.openxmlformats.org/officeDocument/2006/relationships" id="2147483648" r:id="Ra10c9a918d9642cd"/>
   </p:sldMasterIdLst>
   <p:notesMasterIdLst>
-    <p:notesMasterId xmlns:r="http://schemas.openxmlformats.org/officeDocument/2006/relationships" r:id="Rfe631e5d6a574c02"/>
+    <p:notesMasterId xmlns:r="http://schemas.openxmlformats.org/officeDocument/2006/relationships" r:id="Rf997cfaa3a064efe"/>
   </p:notesMasterIdLst>
   <p:sldIdLst>
-    <p:sldId xmlns:r="http://schemas.openxmlformats.org/officeDocument/2006/relationships" id="256" r:id="R5fcf6b0c97fe4b30"/>
-    <p:sldId xmlns:r="http://schemas.openxmlformats.org/officeDocument/2006/relationships" id="257" r:id="R7d206669ea49448a"/>
-    <p:sldId xmlns:r="http://schemas.openxmlformats.org/officeDocument/2006/relationships" id="258" r:id="R0aa142324b0b4ffb"/>
-    <p:sldId xmlns:r="http://schemas.openxmlformats.org/officeDocument/2006/relationships" id="259" r:id="R9570eb875e324177"/>
-    <p:sldId xmlns:r="http://schemas.openxmlformats.org/officeDocument/2006/relationships" id="260" r:id="R019fe010eab44cf4"/>
-    <p:sldId xmlns:r="http://schemas.openxmlformats.org/officeDocument/2006/relationships" id="261" r:id="R7ff8a2e03ce145ca"/>
-    <p:sldId xmlns:r="http://schemas.openxmlformats.org/officeDocument/2006/relationships" id="262" r:id="R21a556a6139d454b"/>
-    <p:sldId xmlns:r="http://schemas.openxmlformats.org/officeDocument/2006/relationships" id="263" r:id="R7903c122ce904d52"/>
-    <p:sldId xmlns:r="http://schemas.openxmlformats.org/officeDocument/2006/relationships" id="264" r:id="R655fa63a81874733"/>
-    <p:sldId xmlns:r="http://schemas.openxmlformats.org/officeDocument/2006/relationships" id="265" r:id="R188cf5debc7c4196"/>
-    <p:sldId xmlns:r="http://schemas.openxmlformats.org/officeDocument/2006/relationships" id="266" r:id="R0cf8989397dc405b"/>
-    <p:sldId xmlns:r="http://schemas.openxmlformats.org/officeDocument/2006/relationships" id="267" r:id="R7af04066a9634b87"/>
-    <p:sldId xmlns:r="http://schemas.openxmlformats.org/officeDocument/2006/relationships" id="268" r:id="Rfeb6d9a3d07f4e76"/>
-    <p:sldId xmlns:r="http://schemas.openxmlformats.org/officeDocument/2006/relationships" id="269" r:id="R8f7b2dc270604a93"/>
-    <p:sldId xmlns:r="http://schemas.openxmlformats.org/officeDocument/2006/relationships" id="270" r:id="Rce9b9f28a4274be5"/>
-    <p:sldId xmlns:r="http://schemas.openxmlformats.org/officeDocument/2006/relationships" id="271" r:id="Rff95d0c47df840d3"/>
-    <p:sldId xmlns:r="http://schemas.openxmlformats.org/officeDocument/2006/relationships" id="272" r:id="R235070bf38674d2d"/>
-    <p:sldId xmlns:r="http://schemas.openxmlformats.org/officeDocument/2006/relationships" id="273" r:id="R42f347deb3d34210"/>
-    <p:sldId xmlns:r="http://schemas.openxmlformats.org/officeDocument/2006/relationships" id="274" r:id="R6e1b3a9094af4712"/>
-    <p:sldId xmlns:r="http://schemas.openxmlformats.org/officeDocument/2006/relationships" id="275" r:id="R0da06360eaa44b72"/>
+    <p:sldId xmlns:r="http://schemas.openxmlformats.org/officeDocument/2006/relationships" id="256" r:id="Rb77f38e4a3604b47"/>
+    <p:sldId xmlns:r="http://schemas.openxmlformats.org/officeDocument/2006/relationships" id="257" r:id="Rbecc512dbcf84e49"/>
+    <p:sldId xmlns:r="http://schemas.openxmlformats.org/officeDocument/2006/relationships" id="258" r:id="R618e3a4925064ecb"/>
+    <p:sldId xmlns:r="http://schemas.openxmlformats.org/officeDocument/2006/relationships" id="259" r:id="R2c8cfe02ed01433a"/>
+    <p:sldId xmlns:r="http://schemas.openxmlformats.org/officeDocument/2006/relationships" id="260" r:id="R8f0ad63bf5104d52"/>
+    <p:sldId xmlns:r="http://schemas.openxmlformats.org/officeDocument/2006/relationships" id="261" r:id="R31fd3b01dc144ca9"/>
+    <p:sldId xmlns:r="http://schemas.openxmlformats.org/officeDocument/2006/relationships" id="262" r:id="R2820f8051def4c20"/>
+    <p:sldId xmlns:r="http://schemas.openxmlformats.org/officeDocument/2006/relationships" id="263" r:id="Rd43aa1336f614dd0"/>
+    <p:sldId xmlns:r="http://schemas.openxmlformats.org/officeDocument/2006/relationships" id="264" r:id="R1f9eaad4cec448c9"/>
+    <p:sldId xmlns:r="http://schemas.openxmlformats.org/officeDocument/2006/relationships" id="265" r:id="Rfbad7aa32c4e4d2f"/>
+    <p:sldId xmlns:r="http://schemas.openxmlformats.org/officeDocument/2006/relationships" id="266" r:id="R25048f15d3a94718"/>
+    <p:sldId xmlns:r="http://schemas.openxmlformats.org/officeDocument/2006/relationships" id="267" r:id="R03a834846a6b4059"/>
+    <p:sldId xmlns:r="http://schemas.openxmlformats.org/officeDocument/2006/relationships" id="268" r:id="R7a7a97d98cb64646"/>
+    <p:sldId xmlns:r="http://schemas.openxmlformats.org/officeDocument/2006/relationships" id="269" r:id="R8d4d07eba24246de"/>
+    <p:sldId xmlns:r="http://schemas.openxmlformats.org/officeDocument/2006/relationships" id="270" r:id="Rfab583f41fb64c57"/>
+    <p:sldId xmlns:r="http://schemas.openxmlformats.org/officeDocument/2006/relationships" id="271" r:id="R04e1351148364dc3"/>
+    <p:sldId xmlns:r="http://schemas.openxmlformats.org/officeDocument/2006/relationships" id="272" r:id="R29d676f3e5e34e9c"/>
+    <p:sldId xmlns:r="http://schemas.openxmlformats.org/officeDocument/2006/relationships" id="273" r:id="Re36853c1c5124654"/>
+    <p:sldId xmlns:r="http://schemas.openxmlformats.org/officeDocument/2006/relationships" id="274" r:id="R048ddb90205b4db7"/>
+    <p:sldId xmlns:r="http://schemas.openxmlformats.org/officeDocument/2006/relationships" id="275" r:id="R8f876b914b2c45b9"/>
   </p:sldIdLst>
   <p:sldSz cx="12191970" cy="6858000"/>
   <p:notesSz cx="6858000" cy="9144000"/>
+  <p:defaultTextStyle>
+    <a:defPPr xmlns:a="http://schemas.openxmlformats.org/drawingml/2006/main">
+      <a:defRPr lang="en-US"/>
+    </a:defPPr>
+    <a:lvl1pPr xmlns:a="http://schemas.openxmlformats.org/drawingml/2006/main" marL="0" indent="0" algn="l" defTabSz="914400">
+      <a:defRPr sz="1800" kern="1200">
+        <a:solidFill>
+          <a:schemeClr val="tx1"/>
+        </a:solidFill>
+        <a:latin typeface="+mn-lt"/>
+        <a:ea typeface="+mn-ea"/>
+        <a:cs typeface="+mn-cs"/>
+      </a:defRPr>
+    </a:lvl1pPr>
+    <a:lvl2pPr xmlns:a="http://schemas.openxmlformats.org/drawingml/2006/main" marL="457200" indent="0" algn="l" defTabSz="914400">
+      <a:defRPr sz="1800" kern="1200">
+        <a:solidFill>
+          <a:schemeClr val="tx1"/>
+        </a:solidFill>
+        <a:latin typeface="+mn-lt"/>
+        <a:ea typeface="+mn-ea"/>
+        <a:cs typeface="+mn-cs"/>
+      </a:defRPr>
+    </a:lvl2pPr>
+    <a:lvl3pPr xmlns:a="http://schemas.openxmlformats.org/drawingml/2006/main" marL="914400" indent="0" algn="l" defTabSz="914400">
+      <a:defRPr sz="1800" kern="1200">
+        <a:solidFill>
+          <a:schemeClr val="tx1"/>
+        </a:solidFill>
+        <a:latin typeface="+mn-lt"/>
+        <a:ea typeface="+mn-ea"/>
+        <a:cs typeface="+mn-cs"/>
+      </a:defRPr>
+    </a:lvl3pPr>
+    <a:lvl4pPr xmlns:a="http://schemas.openxmlformats.org/drawingml/2006/main" marL="1371600" indent="0" algn="l" defTabSz="914400">
+      <a:defRPr sz="1800" kern="1200">
+        <a:solidFill>
+          <a:schemeClr val="tx1"/>
+        </a:solidFill>
+        <a:latin typeface="+mn-lt"/>
+        <a:ea typeface="+mn-ea"/>
+        <a:cs typeface="+mn-cs"/>
+      </a:defRPr>
+    </a:lvl4pPr>
+    <a:lvl5pPr xmlns:a="http://schemas.openxmlformats.org/drawingml/2006/main" marL="1828800" indent="0" algn="l" defTabSz="914400">
+      <a:defRPr sz="1800" kern="1200">
+        <a:solidFill>
+          <a:schemeClr val="tx1"/>
+        </a:solidFill>
+        <a:latin typeface="+mn-lt"/>
+        <a:ea typeface="+mn-ea"/>
+        <a:cs typeface="+mn-cs"/>
+      </a:defRPr>
+    </a:lvl5pPr>
+    <a:lvl6pPr xmlns:a="http://schemas.openxmlformats.org/drawingml/2006/main" marL="2286000" indent="0" algn="l" defTabSz="914400">
+      <a:defRPr sz="1800" kern="1200">
+        <a:solidFill>
+          <a:schemeClr val="tx1"/>
+        </a:solidFill>
+        <a:latin typeface="+mn-lt"/>
+        <a:ea typeface="+mn-ea"/>
+        <a:cs typeface="+mn-cs"/>
+      </a:defRPr>
+    </a:lvl6pPr>
+    <a:lvl7pPr xmlns:a="http://schemas.openxmlformats.org/drawingml/2006/main" marL="2743200" indent="0" algn="l" defTabSz="914400">
+      <a:defRPr sz="1800" kern="1200">
+        <a:solidFill>
+          <a:schemeClr val="tx1"/>
+        </a:solidFill>
+        <a:latin typeface="+mn-lt"/>
+        <a:ea typeface="+mn-ea"/>
+        <a:cs typeface="+mn-cs"/>
+      </a:defRPr>
+    </a:lvl7pPr>
+    <a:lvl8pPr xmlns:a="http://schemas.openxmlformats.org/drawingml/2006/main" marL="3200400" indent="0" algn="l" defTabSz="914400">
+      <a:defRPr sz="1800" kern="1200">
+        <a:solidFill>
+          <a:schemeClr val="tx1"/>
+        </a:solidFill>
+        <a:latin typeface="+mn-lt"/>
+        <a:ea typeface="+mn-ea"/>
+        <a:cs typeface="+mn-cs"/>
+      </a:defRPr>
+    </a:lvl8pPr>
+    <a:lvl9pPr xmlns:a="http://schemas.openxmlformats.org/drawingml/2006/main" marL="3657600" indent="0" algn="l" defTabSz="914400">
+      <a:defRPr sz="1800" kern="1200">
+        <a:solidFill>
+          <a:schemeClr val="tx1"/>
+        </a:solidFill>
+        <a:latin typeface="+mn-lt"/>
+        <a:ea typeface="+mn-ea"/>
+        <a:cs typeface="+mn-cs"/>
+      </a:defRPr>
+    </a:lvl9pPr>
+  </p:defaultTextStyle>
 </p:presentation>
 </file>
 
@@ -503,7 +598,6 @@
             <a:r>
               <a:t/>
             </a:r>
-            <a:endParaRPr/>
           </a:p>
         </p:txBody>
       </p:sp>
@@ -574,7 +668,6 @@
             <a:r>
               <a:t/>
             </a:r>
-            <a:endParaRPr/>
           </a:p>
         </p:txBody>
       </p:sp>
@@ -645,7 +738,6 @@
             <a:r>
               <a:t/>
             </a:r>
-            <a:endParaRPr/>
           </a:p>
         </p:txBody>
       </p:sp>
@@ -716,7 +808,6 @@
             <a:r>
               <a:t/>
             </a:r>
-            <a:endParaRPr/>
           </a:p>
         </p:txBody>
       </p:sp>
@@ -787,7 +878,6 @@
             <a:r>
               <a:t/>
             </a:r>
-            <a:endParaRPr/>
           </a:p>
         </p:txBody>
       </p:sp>
@@ -858,7 +948,6 @@
             <a:r>
               <a:t/>
             </a:r>
-            <a:endParaRPr/>
           </a:p>
         </p:txBody>
       </p:sp>
@@ -929,7 +1018,6 @@
             <a:r>
               <a:t/>
             </a:r>
-            <a:endParaRPr/>
           </a:p>
         </p:txBody>
       </p:sp>
@@ -1000,7 +1088,6 @@
             <a:r>
               <a:t/>
             </a:r>
-            <a:endParaRPr/>
           </a:p>
         </p:txBody>
       </p:sp>
@@ -1071,7 +1158,6 @@
             <a:r>
               <a:t/>
             </a:r>
-            <a:endParaRPr/>
           </a:p>
         </p:txBody>
       </p:sp>
@@ -1142,7 +1228,6 @@
             <a:r>
               <a:t/>
             </a:r>
-            <a:endParaRPr/>
           </a:p>
         </p:txBody>
       </p:sp>
@@ -1213,7 +1298,6 @@
             <a:r>
               <a:t/>
             </a:r>
-            <a:endParaRPr/>
           </a:p>
         </p:txBody>
       </p:sp>
@@ -1284,7 +1368,6 @@
             <a:r>
               <a:t/>
             </a:r>
-            <a:endParaRPr/>
           </a:p>
         </p:txBody>
       </p:sp>
@@ -1355,7 +1438,6 @@
             <a:r>
               <a:t/>
             </a:r>
-            <a:endParaRPr/>
           </a:p>
         </p:txBody>
       </p:sp>
@@ -1426,7 +1508,6 @@
             <a:r>
               <a:t/>
             </a:r>
-            <a:endParaRPr/>
           </a:p>
         </p:txBody>
       </p:sp>
@@ -1497,7 +1578,6 @@
             <a:r>
               <a:t/>
             </a:r>
-            <a:endParaRPr/>
           </a:p>
         </p:txBody>
       </p:sp>
@@ -1568,7 +1648,6 @@
             <a:r>
               <a:t/>
             </a:r>
-            <a:endParaRPr/>
           </a:p>
         </p:txBody>
       </p:sp>
@@ -1639,7 +1718,6 @@
             <a:r>
               <a:t/>
             </a:r>
-            <a:endParaRPr/>
           </a:p>
         </p:txBody>
       </p:sp>
@@ -1710,7 +1788,6 @@
             <a:r>
               <a:t/>
             </a:r>
-            <a:endParaRPr/>
           </a:p>
         </p:txBody>
       </p:sp>
@@ -1781,7 +1858,6 @@
             <a:r>
               <a:t/>
             </a:r>
-            <a:endParaRPr/>
           </a:p>
         </p:txBody>
       </p:sp>
@@ -1852,7 +1928,6 @@
             <a:r>
               <a:t/>
             </a:r>
-            <a:endParaRPr/>
           </a:p>
         </p:txBody>
       </p:sp>
@@ -1919,17 +1994,14 @@
   </p:cSld>
   <p:clrMap bg1="lt1" tx1="dk1" bg2="lt2" tx2="dk2" accent1="accent1" accent2="accent2" accent3="accent3" accent4="accent4" accent5="accent5" accent6="accent6" hlink="hlink" folHlink="folHlink"/>
   <p:sldLayoutIdLst>
-    <p:sldLayoutId xmlns:r="http://schemas.openxmlformats.org/officeDocument/2006/relationships" id="2147483649" r:id="R5680e07429b64974"/>
+    <p:sldLayoutId xmlns:r="http://schemas.openxmlformats.org/officeDocument/2006/relationships" id="2147483649" r:id="R1697b2bfc98a4a22"/>
   </p:sldLayoutIdLst>
   <p:hf sldNum="0" hdr="0" ftr="0" dt="0"/>
   <p:txStyles>
     <p:titleStyle>
-      <a:lvl1pPr xmlns:a="http://schemas.openxmlformats.org/drawingml/2006/main" algn="ctr" defTabSz="914400">
-        <a:spcBef>
-          <a:spcPct val="0"/>
-        </a:spcBef>
+      <a:lvl1pPr xmlns:a="http://schemas.openxmlformats.org/drawingml/2006/main" algn="ctr">
         <a:buNone/>
-        <a:defRPr sz="4400" kern="1200">
+        <a:defRPr sz="4400">
           <a:solidFill>
             <a:schemeClr val="tx1"/>
           </a:solidFill>
@@ -1940,13 +2012,9 @@
       </a:lvl1pPr>
     </p:titleStyle>
     <p:bodyStyle>
-      <a:lvl1pPr xmlns:a="http://schemas.openxmlformats.org/drawingml/2006/main" marL="342900" indent="-342900" algn="l" defTabSz="914400">
-        <a:spcBef>
-          <a:spcPct val="20000"/>
-        </a:spcBef>
-        <a:buFont typeface="Arial"/>
+      <a:lvl1pPr xmlns:a="http://schemas.openxmlformats.org/drawingml/2006/main" marL="342900" indent="-342900" algn="l">
         <a:buChar char="•"/>
-        <a:defRPr sz="3200" kern="1200">
+        <a:defRPr sz="3200">
           <a:solidFill>
             <a:schemeClr val="tx1"/>
           </a:solidFill>
@@ -1955,13 +2023,9 @@
           <a:cs typeface="+mn-lt"/>
         </a:defRPr>
       </a:lvl1pPr>
-      <a:lvl2pPr xmlns:a="http://schemas.openxmlformats.org/drawingml/2006/main" marL="742950" indent="-285750" algn="l" defTabSz="914400">
-        <a:spcBef>
-          <a:spcPct val="20000"/>
-        </a:spcBef>
-        <a:buFont typeface="Arial"/>
+      <a:lvl2pPr xmlns:a="http://schemas.openxmlformats.org/drawingml/2006/main" marL="742950" indent="-285750" algn="l">
         <a:buChar char="–"/>
-        <a:defRPr sz="2800" kern="1200">
+        <a:defRPr sz="2800">
           <a:solidFill>
             <a:schemeClr val="tx1"/>
           </a:solidFill>
@@ -1970,13 +2034,9 @@
           <a:cs typeface="+mn-lt"/>
         </a:defRPr>
       </a:lvl2pPr>
-      <a:lvl3pPr xmlns:a="http://schemas.openxmlformats.org/drawingml/2006/main" marL="1143000" indent="-228600" algn="l" defTabSz="914400">
-        <a:spcBef>
-          <a:spcPct val="20000"/>
-        </a:spcBef>
-        <a:buFont typeface="Arial"/>
+      <a:lvl3pPr xmlns:a="http://schemas.openxmlformats.org/drawingml/2006/main" marL="1143000" indent="-228600" algn="l">
         <a:buChar char="•"/>
-        <a:defRPr sz="2400" kern="1200">
+        <a:defRPr sz="2400">
           <a:solidFill>
             <a:schemeClr val="tx1"/>
           </a:solidFill>
@@ -1985,13 +2045,9 @@
           <a:cs typeface="+mn-lt"/>
         </a:defRPr>
       </a:lvl3pPr>
-      <a:lvl4pPr xmlns:a="http://schemas.openxmlformats.org/drawingml/2006/main" marL="1600200" indent="-228600" algn="l" defTabSz="914400">
-        <a:spcBef>
-          <a:spcPct val="20000"/>
-        </a:spcBef>
-        <a:buFont typeface="Arial"/>
+      <a:lvl4pPr xmlns:a="http://schemas.openxmlformats.org/drawingml/2006/main" marL="1600200" indent="-228600" algn="l">
         <a:buChar char="–"/>
-        <a:defRPr sz="2000" kern="1200">
+        <a:defRPr sz="2000">
           <a:solidFill>
             <a:schemeClr val="tx1"/>
           </a:solidFill>
@@ -2000,13 +2056,9 @@
           <a:cs typeface="+mn-lt"/>
         </a:defRPr>
       </a:lvl4pPr>
-      <a:lvl5pPr xmlns:a="http://schemas.openxmlformats.org/drawingml/2006/main" marL="2057400" indent="-228600" algn="l" defTabSz="914400">
-        <a:spcBef>
-          <a:spcPct val="20000"/>
-        </a:spcBef>
-        <a:buFont typeface="Arial"/>
+      <a:lvl5pPr xmlns:a="http://schemas.openxmlformats.org/drawingml/2006/main" marL="2057400" indent="-228600" algn="l">
         <a:buChar char="»"/>
-        <a:defRPr sz="2000" kern="1200">
+        <a:defRPr sz="2000">
           <a:solidFill>
             <a:schemeClr val="tx1"/>
           </a:solidFill>
@@ -2015,13 +2067,9 @@
           <a:cs typeface="+mn-lt"/>
         </a:defRPr>
       </a:lvl5pPr>
-      <a:lvl6pPr xmlns:a="http://schemas.openxmlformats.org/drawingml/2006/main" marL="2514600" indent="-228600" algn="l" defTabSz="914400">
-        <a:spcBef>
-          <a:spcPct val="20000"/>
-        </a:spcBef>
-        <a:buFont typeface="Arial"/>
+      <a:lvl6pPr xmlns:a="http://schemas.openxmlformats.org/drawingml/2006/main" marL="2514600" indent="-228600" algn="l">
         <a:buChar char="•"/>
-        <a:defRPr sz="2000" kern="1200">
+        <a:defRPr sz="2000">
           <a:solidFill>
             <a:schemeClr val="tx1"/>
           </a:solidFill>
@@ -2030,13 +2078,9 @@
           <a:cs typeface="+mn-lt"/>
         </a:defRPr>
       </a:lvl6pPr>
-      <a:lvl7pPr xmlns:a="http://schemas.openxmlformats.org/drawingml/2006/main" marL="2971800" indent="-228600" algn="l" defTabSz="914400">
-        <a:spcBef>
-          <a:spcPct val="20000"/>
-        </a:spcBef>
-        <a:buFont typeface="Arial"/>
+      <a:lvl7pPr xmlns:a="http://schemas.openxmlformats.org/drawingml/2006/main" marL="2971800" indent="-228600" algn="l">
         <a:buChar char="•"/>
-        <a:defRPr sz="2000" kern="1200">
+        <a:defRPr sz="2000">
           <a:solidFill>
             <a:schemeClr val="tx1"/>
           </a:solidFill>
@@ -2045,13 +2089,9 @@
           <a:cs typeface="+mn-lt"/>
         </a:defRPr>
       </a:lvl7pPr>
-      <a:lvl8pPr xmlns:a="http://schemas.openxmlformats.org/drawingml/2006/main" marL="3429000" indent="-228600" algn="l" defTabSz="914400">
-        <a:spcBef>
-          <a:spcPct val="20000"/>
-        </a:spcBef>
-        <a:buFont typeface="Arial"/>
+      <a:lvl8pPr xmlns:a="http://schemas.openxmlformats.org/drawingml/2006/main" marL="3429000" indent="-228600" algn="l">
         <a:buChar char="•"/>
-        <a:defRPr sz="2000" kern="1200">
+        <a:defRPr sz="2000">
           <a:solidFill>
             <a:schemeClr val="tx1"/>
           </a:solidFill>
@@ -2060,13 +2100,9 @@
           <a:cs typeface="+mn-lt"/>
         </a:defRPr>
       </a:lvl8pPr>
-      <a:lvl9pPr xmlns:a="http://schemas.openxmlformats.org/drawingml/2006/main" marL="3886200" indent="-228600" algn="l" defTabSz="914400">
-        <a:spcBef>
-          <a:spcPct val="20000"/>
-        </a:spcBef>
-        <a:buFont typeface="Arial"/>
+      <a:lvl9pPr xmlns:a="http://schemas.openxmlformats.org/drawingml/2006/main" marL="3886200" indent="-228600" algn="l">
         <a:buChar char="•"/>
-        <a:defRPr sz="2000" kern="1200">
+        <a:defRPr sz="2000">
           <a:solidFill>
             <a:schemeClr val="tx1"/>
           </a:solidFill>
@@ -2077,9 +2113,9 @@
       </a:lvl9pPr>
     </p:bodyStyle>
     <p:otherStyle>
-      <a:lvl1pPr xmlns:a="http://schemas.openxmlformats.org/drawingml/2006/main" marL="0" algn="l" defTabSz="914400">
+      <a:lvl1pPr xmlns:a="http://schemas.openxmlformats.org/drawingml/2006/main" marL="0" algn="l">
         <a:buNone/>
-        <a:defRPr sz="1800" kern="1200">
+        <a:defRPr sz="1800">
           <a:solidFill>
             <a:schemeClr val="tx1"/>
           </a:solidFill>
@@ -2088,9 +2124,9 @@
           <a:cs typeface="+mn-lt"/>
         </a:defRPr>
       </a:lvl1pPr>
-      <a:lvl2pPr xmlns:a="http://schemas.openxmlformats.org/drawingml/2006/main" marL="457200" algn="l" defTabSz="914400">
+      <a:lvl2pPr xmlns:a="http://schemas.openxmlformats.org/drawingml/2006/main" marL="457200" algn="l">
         <a:buNone/>
-        <a:defRPr sz="1800" kern="1200">
+        <a:defRPr sz="1800">
           <a:solidFill>
             <a:schemeClr val="tx1"/>
           </a:solidFill>
@@ -2099,9 +2135,9 @@
           <a:cs typeface="+mn-lt"/>
         </a:defRPr>
       </a:lvl2pPr>
-      <a:lvl3pPr xmlns:a="http://schemas.openxmlformats.org/drawingml/2006/main" marL="914400" algn="l" defTabSz="914400">
+      <a:lvl3pPr xmlns:a="http://schemas.openxmlformats.org/drawingml/2006/main" marL="914400" algn="l">
         <a:buNone/>
-        <a:defRPr sz="1800" kern="1200">
+        <a:defRPr sz="1800">
           <a:solidFill>
             <a:schemeClr val="tx1"/>
           </a:solidFill>
@@ -2110,9 +2146,9 @@
           <a:cs typeface="+mn-lt"/>
         </a:defRPr>
       </a:lvl3pPr>
-      <a:lvl4pPr xmlns:a="http://schemas.openxmlformats.org/drawingml/2006/main" marL="1371600" algn="l" defTabSz="914400">
+      <a:lvl4pPr xmlns:a="http://schemas.openxmlformats.org/drawingml/2006/main" marL="1371600" algn="l">
         <a:buNone/>
-        <a:defRPr sz="1800" kern="1200">
+        <a:defRPr sz="1800">
           <a:solidFill>
             <a:schemeClr val="tx1"/>
           </a:solidFill>
@@ -2121,9 +2157,9 @@
           <a:cs typeface="+mn-lt"/>
         </a:defRPr>
       </a:lvl4pPr>
-      <a:lvl5pPr xmlns:a="http://schemas.openxmlformats.org/drawingml/2006/main" marL="1828800" algn="l" defTabSz="914400">
+      <a:lvl5pPr xmlns:a="http://schemas.openxmlformats.org/drawingml/2006/main" marL="1828800" algn="l">
         <a:buNone/>
-        <a:defRPr sz="1800" kern="1200">
+        <a:defRPr sz="1800">
           <a:solidFill>
             <a:schemeClr val="tx1"/>
           </a:solidFill>
@@ -2132,9 +2168,9 @@
           <a:cs typeface="+mn-lt"/>
         </a:defRPr>
       </a:lvl5pPr>
-      <a:lvl6pPr xmlns:a="http://schemas.openxmlformats.org/drawingml/2006/main" marL="2286000" algn="l" defTabSz="914400">
+      <a:lvl6pPr xmlns:a="http://schemas.openxmlformats.org/drawingml/2006/main" marL="2286000" algn="l">
         <a:buNone/>
-        <a:defRPr sz="1800" kern="1200">
+        <a:defRPr sz="1800">
           <a:solidFill>
             <a:schemeClr val="tx1"/>
           </a:solidFill>
@@ -2143,9 +2179,9 @@
           <a:cs typeface="+mn-lt"/>
         </a:defRPr>
       </a:lvl6pPr>
-      <a:lvl7pPr xmlns:a="http://schemas.openxmlformats.org/drawingml/2006/main" marL="2743200" algn="l" defTabSz="914400">
+      <a:lvl7pPr xmlns:a="http://schemas.openxmlformats.org/drawingml/2006/main" marL="2743200" algn="l">
         <a:buNone/>
-        <a:defRPr sz="1800" kern="1200">
+        <a:defRPr sz="1800">
           <a:solidFill>
             <a:schemeClr val="tx1"/>
           </a:solidFill>
@@ -2154,9 +2190,9 @@
           <a:cs typeface="+mn-lt"/>
         </a:defRPr>
       </a:lvl7pPr>
-      <a:lvl8pPr xmlns:a="http://schemas.openxmlformats.org/drawingml/2006/main" marL="3200400" algn="l" defTabSz="914400">
+      <a:lvl8pPr xmlns:a="http://schemas.openxmlformats.org/drawingml/2006/main" marL="3200400" algn="l">
         <a:buNone/>
-        <a:defRPr sz="1800" kern="1200">
+        <a:defRPr sz="1800">
           <a:solidFill>
             <a:schemeClr val="tx1"/>
           </a:solidFill>
@@ -2165,9 +2201,9 @@
           <a:cs typeface="+mn-lt"/>
         </a:defRPr>
       </a:lvl8pPr>
-      <a:lvl9pPr xmlns:a="http://schemas.openxmlformats.org/drawingml/2006/main" marL="3657600" algn="l" defTabSz="914400">
+      <a:lvl9pPr xmlns:a="http://schemas.openxmlformats.org/drawingml/2006/main" marL="3657600" algn="l">
         <a:buNone/>
-        <a:defRPr sz="1800" kern="1200">
+        <a:defRPr sz="1800">
           <a:solidFill>
             <a:schemeClr val="tx1"/>
           </a:solidFill>
@@ -2532,7 +2568,6 @@
               </a:rPr>
               <a:t>MYSQL SESSION</a:t>
             </a:r>
-            <a:endParaRPr sz="1300"/>
           </a:p>
         </p:txBody>
       </p:sp>
@@ -2583,7 +2618,6 @@
               </a:rPr>
               <a:t>The Next Chapter of MySQL</a:t>
             </a:r>
-            <a:endParaRPr sz="4000"/>
           </a:p>
         </p:txBody>
       </p:sp>
@@ -2634,7 +2668,6 @@
               </a:rPr>
               <a:t>9.7 LTS  &amp;  Community Server YY.MM (26.7)</a:t>
             </a:r>
-            <a:endParaRPr sz="2600"/>
           </a:p>
         </p:txBody>
       </p:sp>
@@ -2716,7 +2749,6 @@
               </a:rPr>
               <a:t>Explore the new and updated releases of 9.7 and 26.7 — and what is coming next in MySQL.</a:t>
             </a:r>
-            <a:endParaRPr sz="1600"/>
           </a:p>
         </p:txBody>
       </p:sp>
@@ -2767,7 +2799,6 @@
               </a:rPr>
               <a:t>AUGUST 2026</a:t>
             </a:r>
-            <a:endParaRPr sz="1200"/>
           </a:p>
         </p:txBody>
       </p:sp>
@@ -2818,7 +2849,6 @@
               </a:rPr>
               <a:t>BASED ON OFFICIAL RELEASE NOTES  |  COMMUNITY + ENTERPRISE</a:t>
             </a:r>
-            <a:endParaRPr sz="1100"/>
           </a:p>
         </p:txBody>
       </p:sp>
@@ -3024,7 +3054,6 @@
               </a:rPr>
               <a:t>JSON DUALITY VIEWS</a:t>
             </a:r>
-            <a:endParaRPr sz="1100"/>
           </a:p>
         </p:txBody>
       </p:sp>
@@ -3075,7 +3104,6 @@
               </a:rPr>
               <a:t>Limits, and how to design the view</a:t>
             </a:r>
-            <a:endParaRPr sz="2600"/>
           </a:p>
         </p:txBody>
       </p:sp>
@@ -3186,7 +3214,6 @@
               </a:rPr>
               <a:t>Poor fit / not supported</a:t>
             </a:r>
-            <a:endParaRPr sz="1800"/>
           </a:p>
         </p:txBody>
       </p:sp>
@@ -3219,7 +3246,6 @@
           <a:lstStyle xmlns:a="http://schemas.openxmlformats.org/drawingml/2006/main"/>
           <a:p xmlns:a="http://schemas.openxmlformats.org/drawingml/2006/main">
             <a:pPr marL="342900" indent="-342900">
-              <a:buSzPct val="100000"/>
               <a:buChar char="•"/>
               <a:defRPr>
                 <a:solidFill>
@@ -3238,11 +3264,9 @@
               </a:rPr>
               <a:t>High-volume append-only facts (clicks, metrics)</a:t>
             </a:r>
-            <a:endParaRPr sz="1500"/>
           </a:p>
           <a:p xmlns:a="http://schemas.openxmlformats.org/drawingml/2006/main">
             <a:pPr marL="342900" indent="-342900">
-              <a:buSzPct val="100000"/>
               <a:buChar char="•"/>
               <a:defRPr>
                 <a:solidFill>
@@ -3261,11 +3285,9 @@
               </a:rPr>
               <a:t>Unbounded nesting or no stable document identity</a:t>
             </a:r>
-            <a:endParaRPr sz="1500"/>
           </a:p>
           <a:p xmlns:a="http://schemas.openxmlformats.org/drawingml/2006/main">
             <a:pPr marL="342900" indent="-342900">
-              <a:buSzPct val="100000"/>
               <a:buChar char="•"/>
               <a:defRPr>
                 <a:solidFill>
@@ -3284,11 +3306,9 @@
               </a:rPr>
               <a:t>LOAD DATA, INSERT … SELECT, REPLACE</a:t>
             </a:r>
-            <a:endParaRPr sz="1500"/>
           </a:p>
           <a:p xmlns:a="http://schemas.openxmlformats.org/drawingml/2006/main">
             <a:pPr marL="342900" indent="-342900">
-              <a:buSzPct val="100000"/>
               <a:buChar char="•"/>
               <a:defRPr>
                 <a:solidFill>
@@ -3307,11 +3327,9 @@
               </a:rPr>
               <a:t>Multi-document UPDATE in one statement</a:t>
             </a:r>
-            <a:endParaRPr sz="1500"/>
           </a:p>
           <a:p xmlns:a="http://schemas.openxmlformats.org/drawingml/2006/main">
             <a:pPr marL="342900" indent="-342900">
-              <a:buSzPct val="100000"/>
               <a:buChar char="•"/>
               <a:defRPr>
                 <a:solidFill>
@@ -3330,7 +3348,6 @@
               </a:rPr>
               <a:t>ON DUPLICATE KEY UPDATE on the view</a:t>
             </a:r>
-            <a:endParaRPr sz="1500"/>
           </a:p>
         </p:txBody>
       </p:sp>
@@ -3414,7 +3431,6 @@
               </a:rPr>
               <a:t>Design rules</a:t>
             </a:r>
-            <a:endParaRPr sz="1800"/>
           </a:p>
         </p:txBody>
       </p:sp>
@@ -3447,7 +3463,6 @@
           <a:lstStyle xmlns:a="http://schemas.openxmlformats.org/drawingml/2006/main"/>
           <a:p xmlns:a="http://schemas.openxmlformats.org/drawingml/2006/main">
             <a:pPr marL="342900" indent="-342900">
-              <a:buSzPct val="100000"/>
               <a:buChar char="•"/>
               <a:defRPr>
                 <a:solidFill>
@@ -3466,11 +3481,9 @@
               </a:rPr>
               <a:t>One view per API aggregate, not a mega-document</a:t>
             </a:r>
-            <a:endParaRPr sz="1500"/>
           </a:p>
           <a:p xmlns:a="http://schemas.openxmlformats.org/drawingml/2006/main">
             <a:pPr marL="342900" indent="-342900">
-              <a:buSzPct val="100000"/>
               <a:buChar char="•"/>
               <a:defRPr>
                 <a:solidFill>
@@ -3489,11 +3502,9 @@
               </a:rPr>
               <a:t>Annotate write rights only where the API may mutate</a:t>
             </a:r>
-            <a:endParaRPr sz="1500"/>
           </a:p>
           <a:p xmlns:a="http://schemas.openxmlformats.org/drawingml/2006/main">
             <a:pPr marL="342900" indent="-342900">
-              <a:buSzPct val="100000"/>
               <a:buChar char="•"/>
               <a:defRPr>
                 <a:solidFill>
@@ -3512,11 +3523,9 @@
               </a:rPr>
               <a:t>Keep AUTO_INCREMENT on tables; 9.7 can propagate keys</a:t>
             </a:r>
-            <a:endParaRPr sz="1500"/>
           </a:p>
           <a:p xmlns:a="http://schemas.openxmlformats.org/drawingml/2006/main">
             <a:pPr marL="342900" indent="-342900">
-              <a:buSzPct val="100000"/>
               <a:buChar char="•"/>
               <a:defRPr>
                 <a:solidFill>
@@ -3535,11 +3544,9 @@
               </a:rPr>
               <a:t>Round-trip _metadata.etag on REST updates</a:t>
             </a:r>
-            <a:endParaRPr sz="1500"/>
           </a:p>
           <a:p xmlns:a="http://schemas.openxmlformats.org/drawingml/2006/main">
             <a:pPr marL="342900" indent="-342900">
-              <a:buSzPct val="100000"/>
               <a:buChar char="•"/>
               <a:defRPr>
                 <a:solidFill>
@@ -3558,7 +3565,6 @@
               </a:rPr>
               <a:t>Keep analytics on base tables, not the view</a:t>
             </a:r>
-            <a:endParaRPr sz="1500"/>
           </a:p>
         </p:txBody>
       </p:sp>
@@ -3636,7 +3642,6 @@
               </a:rPr>
               <a:t>MYSQL 9.7 LTS  |  COMMUNITY SERVER 26.7</a:t>
             </a:r>
-            <a:endParaRPr sz="1000"/>
           </a:p>
         </p:txBody>
       </p:sp>
@@ -3687,7 +3692,6 @@
               </a:rPr>
               <a:t>Duality — limits &amp; design</a:t>
             </a:r>
-            <a:endParaRPr sz="1000"/>
           </a:p>
         </p:txBody>
       </p:sp>
@@ -3738,7 +3742,6 @@
               </a:rPr>
               <a:t>10</a:t>
             </a:r>
-            <a:endParaRPr sz="1200"/>
           </a:p>
         </p:txBody>
       </p:sp>
@@ -3818,7 +3821,6 @@
               </a:rPr>
               <a:t>FEATURE DEEP DIVE</a:t>
             </a:r>
-            <a:endParaRPr sz="1100"/>
           </a:p>
         </p:txBody>
       </p:sp>
@@ -3869,7 +3871,6 @@
               </a:rPr>
               <a:t>Hypergraph Optimizer in Community Edition</a:t>
             </a:r>
-            <a:endParaRPr sz="2600"/>
           </a:p>
         </p:txBody>
       </p:sp>
@@ -3953,7 +3954,6 @@
               </a:rPr>
               <a:t>CLASSICAL PLANNER</a:t>
             </a:r>
-            <a:endParaRPr sz="1200"/>
           </a:p>
         </p:txBody>
       </p:sp>
@@ -4004,7 +4004,6 @@
               </a:rPr>
               <a:t>Left-deep, greedy join enumeration. Fast and reliable for OLTP. Can miss better plans on wide, multi-table analytics-style joins.</a:t>
             </a:r>
-            <a:endParaRPr sz="1600"/>
           </a:p>
         </p:txBody>
       </p:sp>
@@ -4055,7 +4054,6 @@
               </a:rPr>
               <a:t>HYPERGRAPH</a:t>
             </a:r>
-            <a:endParaRPr sz="1200"/>
           </a:p>
         </p:txBody>
       </p:sp>
@@ -4106,7 +4104,6 @@
               </a:rPr>
               <a:t>Broader join-plan search. Enable per session or per statement. Previewed in 8.0 / 9.x Enterprise; now free in 9.7 Community.</a:t>
             </a:r>
-            <a:endParaRPr sz="1600"/>
           </a:p>
         </p:txBody>
       </p:sp>
@@ -4190,7 +4187,6 @@
               </a:rPr>
               <a:t>HOW TO EXPLORE</a:t>
             </a:r>
-            <a:endParaRPr sz="1200"/>
           </a:p>
         </p:txBody>
       </p:sp>
@@ -4241,13 +4237,11 @@
               </a:rPr>
               <a:t>SET optimizer_switch = 'hypergraph_optimizer=on';</a:t>
             </a:r>
-            <a:endParaRPr sz="1500"/>
-          </a:p>
-          <a:p xmlns:a="http://schemas.openxmlformats.org/drawingml/2006/main">
-            <a:pPr marL="0" indent="0">
-              <a:buNone/>
-            </a:pPr>
-            <a:endParaRPr sz="1500"/>
+          </a:p>
+          <a:p xmlns:a="http://schemas.openxmlformats.org/drawingml/2006/main">
+            <a:pPr marL="0" indent="0">
+              <a:buNone/>
+            </a:pPr>
           </a:p>
           <a:p xmlns:a="http://schemas.openxmlformats.org/drawingml/2006/main">
             <a:pPr marL="0" indent="0">
@@ -4269,13 +4263,11 @@
               </a:rPr>
               <a:t>Or use SET_VAR() on a single statement.</a:t>
             </a:r>
-            <a:endParaRPr sz="1500"/>
-          </a:p>
-          <a:p xmlns:a="http://schemas.openxmlformats.org/drawingml/2006/main">
-            <a:pPr marL="0" indent="0">
-              <a:buNone/>
-            </a:pPr>
-            <a:endParaRPr sz="1500"/>
+          </a:p>
+          <a:p xmlns:a="http://schemas.openxmlformats.org/drawingml/2006/main">
+            <a:pPr marL="0" indent="0">
+              <a:buNone/>
+            </a:pPr>
           </a:p>
           <a:p xmlns:a="http://schemas.openxmlformats.org/drawingml/2006/main">
             <a:pPr marL="0" indent="0">
@@ -4297,13 +4289,11 @@
               </a:rPr>
               <a:t>Compare EXPLAIN / EXPLAIN ANALYZE on your worst multi-join queries before and after.</a:t>
             </a:r>
-            <a:endParaRPr sz="1500"/>
-          </a:p>
-          <a:p xmlns:a="http://schemas.openxmlformats.org/drawingml/2006/main">
-            <a:pPr marL="0" indent="0">
-              <a:buNone/>
-            </a:pPr>
-            <a:endParaRPr sz="1500"/>
+          </a:p>
+          <a:p xmlns:a="http://schemas.openxmlformats.org/drawingml/2006/main">
+            <a:pPr marL="0" indent="0">
+              <a:buNone/>
+            </a:pPr>
           </a:p>
           <a:p xmlns:a="http://schemas.openxmlformats.org/drawingml/2006/main">
             <a:pPr marL="0" indent="0">
@@ -4325,7 +4315,6 @@
               </a:rPr>
               <a:t>Keep SET_VAR ready both ways — a few queries may still prefer the classical plan.</a:t>
             </a:r>
-            <a:endParaRPr sz="1500"/>
           </a:p>
         </p:txBody>
       </p:sp>
@@ -4403,7 +4392,6 @@
               </a:rPr>
               <a:t>MYSQL 9.7 LTS  |  COMMUNITY SERVER 26.7</a:t>
             </a:r>
-            <a:endParaRPr sz="1000"/>
           </a:p>
         </p:txBody>
       </p:sp>
@@ -4454,7 +4442,6 @@
               </a:rPr>
               <a:t>Hypergraph Optimizer</a:t>
             </a:r>
-            <a:endParaRPr sz="1000"/>
           </a:p>
         </p:txBody>
       </p:sp>
@@ -4505,7 +4492,6 @@
               </a:rPr>
               <a:t>11</a:t>
             </a:r>
-            <a:endParaRPr sz="1200"/>
           </a:p>
         </p:txBody>
       </p:sp>
@@ -4585,7 +4571,6 @@
               </a:rPr>
               <a:t>MYSQL 9.7 LTS</a:t>
             </a:r>
-            <a:endParaRPr sz="1100"/>
           </a:p>
         </p:txBody>
       </p:sp>
@@ -4636,7 +4621,6 @@
               </a:rPr>
               <a:t>Group Replication you can actually see</a:t>
             </a:r>
-            <a:endParaRPr sz="2600"/>
           </a:p>
         </p:txBody>
       </p:sp>
@@ -4720,7 +4704,6 @@
               </a:rPr>
               <a:t>Replication Applier Metrics</a:t>
             </a:r>
-            <a:endParaRPr sz="1600"/>
           </a:p>
         </p:txBody>
       </p:sp>
@@ -4771,7 +4754,6 @@
               </a:rPr>
               <a:t>Lag, throughput, and worker behavior for async and Group Replication appliers.</a:t>
             </a:r>
-            <a:endParaRPr sz="1400"/>
           </a:p>
         </p:txBody>
       </p:sp>
@@ -4855,7 +4837,6 @@
               </a:rPr>
               <a:t>Flow-control statistics</a:t>
             </a:r>
-            <a:endParaRPr sz="1600"/>
           </a:p>
         </p:txBody>
       </p:sp>
@@ -4906,7 +4887,6 @@
               </a:rPr>
               <a:t>When the group is throttling, and how hard — not just a binary “on/off”.</a:t>
             </a:r>
-            <a:endParaRPr sz="1400"/>
           </a:p>
         </p:txBody>
       </p:sp>
@@ -4990,7 +4970,6 @@
               </a:rPr>
               <a:t>Resource Manager</a:t>
             </a:r>
-            <a:endParaRPr sz="1600"/>
           </a:p>
         </p:txBody>
       </p:sp>
@@ -5041,7 +5020,6 @@
               </a:rPr>
               <a:t>Detect unhealthy members, evict them, and rejoin automatically when they recover.</a:t>
             </a:r>
-            <a:endParaRPr sz="1400"/>
           </a:p>
         </p:txBody>
       </p:sp>
@@ -5125,7 +5103,6 @@
               </a:rPr>
               <a:t>Primary election</a:t>
             </a:r>
-            <a:endParaRPr sz="1600"/>
           </a:p>
         </p:txBody>
       </p:sp>
@@ -5176,7 +5153,6 @@
               </a:rPr>
               <a:t>Prefer the most current eligible secondary (least backlog) on failover.</a:t>
             </a:r>
-            <a:endParaRPr sz="1400"/>
           </a:p>
         </p:txBody>
       </p:sp>
@@ -5260,7 +5236,6 @@
               </a:rPr>
               <a:t>Telemetry</a:t>
             </a:r>
-            <a:endParaRPr sz="1600"/>
           </a:p>
         </p:txBody>
       </p:sp>
@@ -5311,7 +5286,6 @@
               </a:rPr>
               <a:t>Ship logs, metrics, and traces into the same OTel stack as the rest of the platform.</a:t>
             </a:r>
-            <a:endParaRPr sz="1400"/>
           </a:p>
         </p:txBody>
       </p:sp>
@@ -5389,7 +5363,6 @@
               </a:rPr>
               <a:t>MYSQL 9.7 LTS  |  COMMUNITY SERVER 26.7</a:t>
             </a:r>
-            <a:endParaRPr sz="1000"/>
           </a:p>
         </p:txBody>
       </p:sp>
@@ -5440,7 +5413,6 @@
               </a:rPr>
               <a:t>HA &amp; observability</a:t>
             </a:r>
-            <a:endParaRPr sz="1000"/>
           </a:p>
         </p:txBody>
       </p:sp>
@@ -5491,7 +5463,6 @@
               </a:rPr>
               <a:t>12</a:t>
             </a:r>
-            <a:endParaRPr sz="1200"/>
           </a:p>
         </p:txBody>
       </p:sp>
@@ -5571,7 +5542,6 @@
               </a:rPr>
               <a:t>MYSQL 26.7 INNOVATION</a:t>
             </a:r>
-            <a:endParaRPr sz="1100"/>
           </a:p>
         </p:txBody>
       </p:sp>
@@ -5622,7 +5592,6 @@
               </a:rPr>
               <a:t>First CalVer Innovation GA after 9.7 LTS</a:t>
             </a:r>
-            <a:endParaRPr sz="2600"/>
           </a:p>
         </p:txBody>
       </p:sp>
@@ -5733,7 +5702,6 @@
               </a:rPr>
               <a:t>Change Stream Applier</a:t>
             </a:r>
-            <a:endParaRPr sz="1600"/>
           </a:p>
         </p:txBody>
       </p:sp>
@@ -5784,7 +5752,6 @@
               </a:rPr>
               <a:t>New multithreaded replica SQL applier. Opt-in per channel via APPLIER_VERSION=2.</a:t>
             </a:r>
-            <a:endParaRPr sz="1400"/>
           </a:p>
         </p:txBody>
       </p:sp>
@@ -5895,7 +5862,6 @@
               </a:rPr>
               <a:t>Thread Pool (Community)</a:t>
             </a:r>
-            <a:endParaRPr sz="1600"/>
           </a:p>
         </p:txBody>
       </p:sp>
@@ -5946,7 +5912,6 @@
               </a:rPr>
               <a:t>Shared statement-execution threads for high-connection workloads. No longer Enterprise-only.</a:t>
             </a:r>
-            <a:endParaRPr sz="1400"/>
           </a:p>
         </p:txBody>
       </p:sp>
@@ -6057,7 +6022,6 @@
               </a:rPr>
               <a:t>GR MYSQL stack default</a:t>
             </a:r>
-            <a:endParaRPr sz="1600"/>
           </a:p>
         </p:txBody>
       </p:sp>
@@ -6108,7 +6072,6 @@
               </a:rPr>
               <a:t>Group Replication defaults to MYSQL communication. XCom options deprecated.</a:t>
             </a:r>
-            <a:endParaRPr sz="1400"/>
           </a:p>
         </p:txBody>
       </p:sp>
@@ -6219,7 +6182,6 @@
               </a:rPr>
               <a:t>InnoDB undo truncation</a:t>
             </a:r>
-            <a:endParaRPr sz="1600"/>
           </a:p>
         </p:txBody>
       </p:sp>
@@ -6270,7 +6232,6 @@
               </a:rPr>
               <a:t>Progress stored in the undo header, not local truncation logs. More robust recovery.</a:t>
             </a:r>
-            <a:endParaRPr sz="1400"/>
           </a:p>
         </p:txBody>
       </p:sp>
@@ -6381,7 +6342,6 @@
               </a:rPr>
               <a:t>Post-quantum TLS</a:t>
             </a:r>
-            <a:endParaRPr sz="1600"/>
           </a:p>
         </p:txBody>
       </p:sp>
@@ -6432,7 +6392,6 @@
               </a:rPr>
               <a:t>ML-KEM hybrid and pure groups when built with OpenSSL 3.5+.</a:t>
             </a:r>
-            <a:endParaRPr sz="1400"/>
           </a:p>
         </p:txBody>
       </p:sp>
@@ -6543,7 +6502,6 @@
               </a:rPr>
               <a:t>Upgrade-check progress</a:t>
             </a:r>
-            <a:endParaRPr sz="1600"/>
           </a:p>
         </p:txBody>
       </p:sp>
@@ -6594,7 +6552,6 @@
               </a:rPr>
               <a:t>Long compatibility checks report phase progress so they do not look stalled.</a:t>
             </a:r>
-            <a:endParaRPr sz="1400"/>
           </a:p>
         </p:txBody>
       </p:sp>
@@ -6672,7 +6629,6 @@
               </a:rPr>
               <a:t>MYSQL 9.7 LTS  |  COMMUNITY SERVER 26.7</a:t>
             </a:r>
-            <a:endParaRPr sz="1000"/>
           </a:p>
         </p:txBody>
       </p:sp>
@@ -6723,7 +6679,6 @@
               </a:rPr>
               <a:t>26.7 overview</a:t>
             </a:r>
-            <a:endParaRPr sz="1000"/>
           </a:p>
         </p:txBody>
       </p:sp>
@@ -6774,7 +6729,6 @@
               </a:rPr>
               <a:t>13</a:t>
             </a:r>
-            <a:endParaRPr sz="1200"/>
           </a:p>
         </p:txBody>
       </p:sp>
@@ -6854,7 +6808,6 @@
               </a:rPr>
               <a:t>FEATURE DEEP DIVE</a:t>
             </a:r>
-            <a:endParaRPr sz="1100"/>
           </a:p>
         </p:txBody>
       </p:sp>
@@ -6905,7 +6858,6 @@
               </a:rPr>
               <a:t>Change Stream Applier (CSA)</a:t>
             </a:r>
-            <a:endParaRPr sz="2600"/>
           </a:p>
         </p:txBody>
       </p:sp>
@@ -6989,7 +6941,6 @@
               </a:rPr>
               <a:t>Opt-in alternative to the Multi-Threaded Applier. Same relay log and channel commands. Modular schedule/execute design — foundation for later replication work.</a:t>
             </a:r>
-            <a:endParaRPr sz="1600"/>
           </a:p>
         </p:txBody>
       </p:sp>
@@ -7073,7 +7024,6 @@
               </a:rPr>
               <a:t>1–1,024</a:t>
             </a:r>
-            <a:endParaRPr sz="2000"/>
           </a:p>
         </p:txBody>
       </p:sp>
@@ -7124,7 +7074,6 @@
               </a:rPr>
               <a:t>Worker threads per channel</a:t>
             </a:r>
-            <a:endParaRPr sz="1400"/>
           </a:p>
         </p:txBody>
       </p:sp>
@@ -7208,7 +7157,6 @@
               </a:rPr>
               <a:t>Per channel</a:t>
             </a:r>
-            <a:endParaRPr sz="2000"/>
           </a:p>
         </p:txBody>
       </p:sp>
@@ -7259,7 +7207,6 @@
               </a:rPr>
               <a:t>Independent applier config</a:t>
             </a:r>
-            <a:endParaRPr sz="1400"/>
           </a:p>
         </p:txBody>
       </p:sp>
@@ -7343,7 +7290,6 @@
               </a:rPr>
               <a:t>Split path</a:t>
             </a:r>
-            <a:endParaRPr sz="2000"/>
           </a:p>
         </p:txBody>
       </p:sp>
@@ -7394,7 +7340,6 @@
               </a:rPr>
               <a:t>Apply vs commit ordering</a:t>
             </a:r>
-            <a:endParaRPr sz="1400"/>
           </a:p>
         </p:txBody>
       </p:sp>
@@ -7478,7 +7423,6 @@
               </a:rPr>
               <a:t>P_S</a:t>
             </a:r>
-            <a:endParaRPr sz="2000"/>
           </a:p>
         </p:txBody>
       </p:sp>
@@ -7529,7 +7473,6 @@
               </a:rPr>
               <a:t>Config + worker visibility</a:t>
             </a:r>
-            <a:endParaRPr sz="1400"/>
           </a:p>
         </p:txBody>
       </p:sp>
@@ -7580,7 +7523,6 @@
               </a:rPr>
               <a:t>Enable with APPLIER_VERSION=2 on a supported channel. Keep APPLIER_VERSION=1 (classic MTA) as the fallback. Also watch STOP REPLICA responsiveness and per-channel event-memory controls.</a:t>
             </a:r>
-            <a:endParaRPr sz="1500"/>
           </a:p>
         </p:txBody>
       </p:sp>
@@ -7631,7 +7573,6 @@
               </a:rPr>
               <a:t>Worklog context: WL#10500 — MTA: Optimized and generic change stream applier.</a:t>
             </a:r>
-            <a:endParaRPr sz="1300"/>
           </a:p>
         </p:txBody>
       </p:sp>
@@ -7709,7 +7650,6 @@
               </a:rPr>
               <a:t>MYSQL 9.7 LTS  |  COMMUNITY SERVER 26.7</a:t>
             </a:r>
-            <a:endParaRPr sz="1000"/>
           </a:p>
         </p:txBody>
       </p:sp>
@@ -7760,7 +7700,6 @@
               </a:rPr>
               <a:t>Change Stream Applier</a:t>
             </a:r>
-            <a:endParaRPr sz="1000"/>
           </a:p>
         </p:txBody>
       </p:sp>
@@ -7811,7 +7750,6 @@
               </a:rPr>
               <a:t>14</a:t>
             </a:r>
-            <a:endParaRPr sz="1200"/>
           </a:p>
         </p:txBody>
       </p:sp>
@@ -7891,7 +7829,6 @@
               </a:rPr>
               <a:t>MYSQL 26.7 INNOVATION</a:t>
             </a:r>
-            <a:endParaRPr sz="1100"/>
           </a:p>
         </p:txBody>
       </p:sp>
@@ -7942,7 +7879,6 @@
               </a:rPr>
               <a:t>Connections and Group Replication stack</a:t>
             </a:r>
-            <a:endParaRPr sz="2600"/>
           </a:p>
         </p:txBody>
       </p:sp>
@@ -8053,7 +7989,6 @@
               </a:rPr>
               <a:t>Thread Pool Plugin</a:t>
             </a:r>
-            <a:endParaRPr sz="2200"/>
           </a:p>
         </p:txBody>
       </p:sp>
@@ -8104,7 +8039,6 @@
               </a:rPr>
               <a:t>Now in Community Edition. Replaces one-thread-per-connection with a managed pool of statement-execution threads.</a:t>
             </a:r>
-            <a:endParaRPr sz="1500"/>
           </a:p>
         </p:txBody>
       </p:sp>
@@ -8137,7 +8071,6 @@
           <a:lstStyle xmlns:a="http://schemas.openxmlformats.org/drawingml/2006/main"/>
           <a:p xmlns:a="http://schemas.openxmlformats.org/drawingml/2006/main">
             <a:pPr marL="342900" indent="-342900">
-              <a:buSzPct val="100000"/>
               <a:buChar char="•"/>
               <a:defRPr>
                 <a:solidFill>
@@ -8156,11 +8089,9 @@
               </a:rPr>
               <a:t>Fewer context switches under thousands of clients</a:t>
             </a:r>
-            <a:endParaRPr sz="1500"/>
           </a:p>
           <a:p xmlns:a="http://schemas.openxmlformats.org/drawingml/2006/main">
             <a:pPr marL="342900" indent="-342900">
-              <a:buSzPct val="100000"/>
               <a:buChar char="•"/>
               <a:defRPr>
                 <a:solidFill>
@@ -8179,11 +8110,9 @@
               </a:rPr>
               <a:t>Lower OS scheduler pressure</a:t>
             </a:r>
-            <a:endParaRPr sz="1500"/>
           </a:p>
           <a:p xmlns:a="http://schemas.openxmlformats.org/drawingml/2006/main">
             <a:pPr marL="342900" indent="-342900">
-              <a:buSzPct val="100000"/>
               <a:buChar char="•"/>
               <a:defRPr>
                 <a:solidFill>
@@ -8202,7 +8131,6 @@
               </a:rPr>
               <a:t>Evaluate on connection-heavy OLTP before production</a:t>
             </a:r>
-            <a:endParaRPr sz="1500"/>
           </a:p>
         </p:txBody>
       </p:sp>
@@ -8313,7 +8241,6 @@
               </a:rPr>
               <a:t>GR communication stack</a:t>
             </a:r>
-            <a:endParaRPr sz="2200"/>
           </a:p>
         </p:txBody>
       </p:sp>
@@ -8364,7 +8291,6 @@
               </a:rPr>
               <a:t>Default changes from XCOM to MYSQL. Uses server connection security and authentication.</a:t>
             </a:r>
-            <a:endParaRPr sz="1500"/>
           </a:p>
         </p:txBody>
       </p:sp>
@@ -8397,7 +8323,6 @@
           <a:lstStyle xmlns:a="http://schemas.openxmlformats.org/drawingml/2006/main"/>
           <a:p xmlns:a="http://schemas.openxmlformats.org/drawingml/2006/main">
             <a:pPr marL="342900" indent="-342900">
-              <a:buSzPct val="100000"/>
               <a:buChar char="•"/>
               <a:defRPr>
                 <a:solidFill>
@@ -8416,11 +8341,9 @@
               </a:rPr>
               <a:t>All members must use the same stack</a:t>
             </a:r>
-            <a:endParaRPr sz="1500"/>
           </a:p>
           <a:p xmlns:a="http://schemas.openxmlformats.org/drawingml/2006/main">
             <a:pPr marL="342900" indent="-342900">
-              <a:buSzPct val="100000"/>
               <a:buChar char="•"/>
               <a:defRPr>
                 <a:solidFill>
@@ -8439,11 +8362,9 @@
               </a:rPr>
               <a:t>XCom-related options emit deprecation warnings</a:t>
             </a:r>
-            <a:endParaRPr sz="1500"/>
           </a:p>
           <a:p xmlns:a="http://schemas.openxmlformats.org/drawingml/2006/main">
             <a:pPr marL="342900" indent="-342900">
-              <a:buSzPct val="100000"/>
               <a:buChar char="•"/>
               <a:defRPr>
                 <a:solidFill>
@@ -8462,11 +8383,9 @@
               </a:rPr>
               <a:t>InnoDB Cluster already uses MYSQL — less impact</a:t>
             </a:r>
-            <a:endParaRPr sz="1500"/>
           </a:p>
           <a:p xmlns:a="http://schemas.openxmlformats.org/drawingml/2006/main">
             <a:pPr marL="342900" indent="-342900">
-              <a:buSzPct val="100000"/>
               <a:buChar char="•"/>
               <a:defRPr>
                 <a:solidFill>
@@ -8485,7 +8404,6 @@
               </a:rPr>
               <a:t>Plan a coordinated cutover for classic GR groups</a:t>
             </a:r>
-            <a:endParaRPr sz="1500"/>
           </a:p>
         </p:txBody>
       </p:sp>
@@ -8563,7 +8481,6 @@
               </a:rPr>
               <a:t>MYSQL 9.7 LTS  |  COMMUNITY SERVER 26.7</a:t>
             </a:r>
-            <a:endParaRPr sz="1000"/>
           </a:p>
         </p:txBody>
       </p:sp>
@@ -8614,7 +8531,6 @@
               </a:rPr>
               <a:t>Runtime &amp; GR</a:t>
             </a:r>
-            <a:endParaRPr sz="1000"/>
           </a:p>
         </p:txBody>
       </p:sp>
@@ -8665,7 +8581,6 @@
               </a:rPr>
               <a:t>15</a:t>
             </a:r>
-            <a:endParaRPr sz="1200"/>
           </a:p>
         </p:txBody>
       </p:sp>
@@ -8745,7 +8660,6 @@
               </a:rPr>
               <a:t>ENTERPRISE EDITION</a:t>
             </a:r>
-            <a:endParaRPr sz="1100"/>
           </a:p>
         </p:txBody>
       </p:sp>
@@ -8796,7 +8710,6 @@
               </a:rPr>
               <a:t>Dynamic Data Masking and audit operations</a:t>
             </a:r>
-            <a:endParaRPr sz="2600"/>
           </a:p>
         </p:txBody>
       </p:sp>
@@ -8880,7 +8793,6 @@
               </a:rPr>
               <a:t>DYNAMIC DATA MASKING</a:t>
             </a:r>
-            <a:endParaRPr sz="1200"/>
           </a:p>
         </p:txBody>
       </p:sp>
@@ -8931,7 +8843,6 @@
               </a:rPr>
               <a:t>Policy on the column. Mask or reveal at query time by user or role. No app rewrite. No second copy of production.</a:t>
             </a:r>
-            <a:endParaRPr sz="1600"/>
           </a:p>
         </p:txBody>
       </p:sp>
@@ -8964,7 +8875,6 @@
           <a:lstStyle xmlns:a="http://schemas.openxmlformats.org/drawingml/2006/main"/>
           <a:p xmlns:a="http://schemas.openxmlformats.org/drawingml/2006/main">
             <a:pPr marL="342900" indent="-342900">
-              <a:buSzPct val="100000"/>
               <a:buChar char="•"/>
               <a:defRPr>
                 <a:solidFill>
@@ -8983,11 +8893,9 @@
               </a:rPr>
               <a:t>SSNs, emails, phones, and other identifiers</a:t>
             </a:r>
-            <a:endParaRPr sz="1600"/>
           </a:p>
           <a:p xmlns:a="http://schemas.openxmlformats.org/drawingml/2006/main">
             <a:pPr marL="342900" indent="-342900">
-              <a:buSzPct val="100000"/>
               <a:buChar char="•"/>
               <a:defRPr>
                 <a:solidFill>
@@ -9006,11 +8914,9 @@
               </a:rPr>
               <a:t>Consistent across reporting, analytics, and AI queries</a:t>
             </a:r>
-            <a:endParaRPr sz="1600"/>
           </a:p>
           <a:p xmlns:a="http://schemas.openxmlformats.org/drawingml/2006/main">
             <a:pPr marL="342900" indent="-342900">
-              <a:buSzPct val="100000"/>
               <a:buChar char="•"/>
               <a:defRPr>
                 <a:solidFill>
@@ -9029,7 +8935,6 @@
               </a:rPr>
               <a:t>Shipped in 9.7 LTS and available in 26.7 Innovation</a:t>
             </a:r>
-            <a:endParaRPr sz="1600"/>
           </a:p>
         </p:txBody>
       </p:sp>
@@ -9113,7 +9018,6 @@
               </a:rPr>
               <a:t>Audit log files</a:t>
             </a:r>
-            <a:endParaRPr sz="1600"/>
           </a:p>
         </p:txBody>
       </p:sp>
@@ -9164,7 +9068,6 @@
               </a:rPr>
               <a:t>audit_log_file_count / audit_log.file_count for JSON audit logs — detect stalled offload.</a:t>
             </a:r>
-            <a:endParaRPr sz="1400"/>
           </a:p>
         </p:txBody>
       </p:sp>
@@ -9248,7 +9151,6 @@
               </a:rPr>
               <a:t>9.7 audit extras</a:t>
             </a:r>
-            <a:endParaRPr sz="1600"/>
           </a:p>
         </p:txBody>
       </p:sp>
@@ -9299,7 +9201,6 @@
               </a:rPr>
               <a:t>Time-based log rotation and safer filter recovery at startup if a filter config is invalid.</a:t>
             </a:r>
-            <a:endParaRPr sz="1400"/>
           </a:p>
         </p:txBody>
       </p:sp>
@@ -9377,7 +9278,6 @@
               </a:rPr>
               <a:t>MYSQL 9.7 LTS  |  COMMUNITY SERVER 26.7</a:t>
             </a:r>
-            <a:endParaRPr sz="1000"/>
           </a:p>
         </p:txBody>
       </p:sp>
@@ -9428,7 +9328,6 @@
               </a:rPr>
               <a:t>Enterprise</a:t>
             </a:r>
-            <a:endParaRPr sz="1000"/>
           </a:p>
         </p:txBody>
       </p:sp>
@@ -9479,7 +9378,6 @@
               </a:rPr>
               <a:t>16</a:t>
             </a:r>
-            <a:endParaRPr sz="1200"/>
           </a:p>
         </p:txBody>
       </p:sp>
@@ -9559,7 +9457,6 @@
               </a:rPr>
               <a:t>ALSO IN THESE RELEASES</a:t>
             </a:r>
-            <a:endParaRPr sz="1100"/>
           </a:p>
         </p:txBody>
       </p:sp>
@@ -9610,7 +9507,6 @@
               </a:rPr>
               <a:t>Smaller changes that still affect operations</a:t>
             </a:r>
-            <a:endParaRPr sz="2600"/>
           </a:p>
         </p:txBody>
       </p:sp>
@@ -9694,7 +9590,6 @@
               </a:rPr>
               <a:t>Security</a:t>
             </a:r>
-            <a:endParaRPr sz="1300"/>
           </a:p>
         </p:txBody>
       </p:sp>
@@ -9778,7 +9673,6 @@
               </a:rPr>
               <a:t>PBKDF2 storage for caching_sha2_password (9.7). SCRAM-SHA-1 deprecated — use SCRAM-SHA-256.</a:t>
             </a:r>
-            <a:endParaRPr sz="1400"/>
           </a:p>
         </p:txBody>
       </p:sp>
@@ -9862,7 +9756,6 @@
               </a:rPr>
               <a:t>Replication knobs</a:t>
             </a:r>
-            <a:endParaRPr sz="1300"/>
           </a:p>
         </p:txBody>
       </p:sp>
@@ -9946,7 +9839,6 @@
               </a:rPr>
               <a:t>replica_allow_higher_version_source. replica_parallel_type removed. Several replication variables deprecated in 9.7.2.</a:t>
             </a:r>
-            <a:endParaRPr sz="1400"/>
           </a:p>
         </p:txBody>
       </p:sp>
@@ -10030,7 +9922,6 @@
               </a:rPr>
               <a:t>Clone</a:t>
             </a:r>
-            <a:endParaRPr sz="1300"/>
           </a:p>
         </p:txBody>
       </p:sp>
@@ -10114,7 +10005,6 @@
               </a:rPr>
               <a:t>Clone plugin can clone between consecutive LTS versions higher than 9.7.0.</a:t>
             </a:r>
-            <a:endParaRPr sz="1400"/>
           </a:p>
         </p:txBody>
       </p:sp>
@@ -10198,7 +10088,6 @@
               </a:rPr>
               <a:t>InnoDB defaults</a:t>
             </a:r>
-            <a:endParaRPr sz="1300"/>
           </a:p>
         </p:txBody>
       </p:sp>
@@ -10282,7 +10171,6 @@
               </a:rPr>
               <a:t>innodb_log_writer_threads default now depends on binary logging and CPU count.</a:t>
             </a:r>
-            <a:endParaRPr sz="1400"/>
           </a:p>
         </p:txBody>
       </p:sp>
@@ -10366,7 +10254,6 @@
               </a:rPr>
               <a:t>Binlog history</a:t>
             </a:r>
-            <a:endParaRPr sz="1300"/>
           </a:p>
         </p:txBody>
       </p:sp>
@@ -10450,7 +10337,6 @@
               </a:rPr>
               <a:t>binlog_transaction_dependency_history_size default raised (from 9.5) to 1,000,000; max 10,000,000.</a:t>
             </a:r>
-            <a:endParaRPr sz="1400"/>
           </a:p>
         </p:txBody>
       </p:sp>
@@ -10534,7 +10420,6 @@
               </a:rPr>
               <a:t>Clients &amp; tools</a:t>
             </a:r>
-            <a:endParaRPr sz="1300"/>
           </a:p>
         </p:txBody>
       </p:sp>
@@ -10618,7 +10503,6 @@
               </a:rPr>
               <a:t>Shell, Router, Operator, connectors move to a single 26.7 line; remain compatible with 8.4 and 9.7 servers.</a:t>
             </a:r>
-            <a:endParaRPr sz="1400"/>
           </a:p>
         </p:txBody>
       </p:sp>
@@ -10696,7 +10580,6 @@
               </a:rPr>
               <a:t>MYSQL 9.7 LTS  |  COMMUNITY SERVER 26.7</a:t>
             </a:r>
-            <a:endParaRPr sz="1000"/>
           </a:p>
         </p:txBody>
       </p:sp>
@@ -10747,7 +10630,6 @@
               </a:rPr>
               <a:t>Also shipped</a:t>
             </a:r>
-            <a:endParaRPr sz="1000"/>
           </a:p>
         </p:txBody>
       </p:sp>
@@ -10798,7 +10680,6 @@
               </a:rPr>
               <a:t>17</a:t>
             </a:r>
-            <a:endParaRPr sz="1200"/>
           </a:p>
         </p:txBody>
       </p:sp>
@@ -10878,7 +10759,6 @@
               </a:rPr>
               <a:t>LOOKING FORWARD</a:t>
             </a:r>
-            <a:endParaRPr sz="1100"/>
           </a:p>
         </p:txBody>
       </p:sp>
@@ -10929,7 +10809,6 @@
               </a:rPr>
               <a:t>What is coming, and how to stay aligned</a:t>
             </a:r>
-            <a:endParaRPr sz="2600"/>
           </a:p>
         </p:txBody>
       </p:sp>
@@ -11013,7 +10892,6 @@
               </a:rPr>
               <a:t>October 2026 window</a:t>
             </a:r>
-            <a:endParaRPr sz="1800"/>
           </a:p>
         </p:txBody>
       </p:sp>
@@ -11064,7 +10942,6 @@
               </a:rPr>
               <a:t>Expect 26.10.0 Innovation plus quarterly 9.7 and 8.4 maintenance, aligned with Oracle CPU cadence.</a:t>
             </a:r>
-            <a:endParaRPr sz="1500"/>
           </a:p>
         </p:txBody>
       </p:sp>
@@ -11148,7 +11025,6 @@
               </a:rPr>
               <a:t>Innovation pace</a:t>
             </a:r>
-            <a:endParaRPr sz="1800"/>
           </a:p>
         </p:txBody>
       </p:sp>
@@ -11199,7 +11075,6 @@
               </a:rPr>
               <a:t>CSA is explicitly a foundation. Watch follow-on replication, GR stack cleanup, and further Community promotions.</a:t>
             </a:r>
-            <a:endParaRPr sz="1500"/>
           </a:p>
         </p:txBody>
       </p:sp>
@@ -11283,7 +11158,6 @@
               </a:rPr>
               <a:t>Stay current</a:t>
             </a:r>
-            <a:endParaRPr sz="1800"/>
           </a:p>
         </p:txBody>
       </p:sp>
@@ -11334,7 +11208,6 @@
               </a:rPr>
               <a:t>Use latest Shell / Router / connectors even on 9.7 or 8.4 servers. Read each quarter’s notes before patching.</a:t>
             </a:r>
-            <a:endParaRPr sz="1500"/>
           </a:p>
         </p:txBody>
       </p:sp>
@@ -11385,7 +11258,6 @@
               </a:rPr>
               <a:t>Principle: LTS for the fleet you must keep still. Innovation for the environments that can absorb quarterly change — and for learning what the next LTS will inherit.</a:t>
             </a:r>
-            <a:endParaRPr sz="1500"/>
           </a:p>
         </p:txBody>
       </p:sp>
@@ -11463,7 +11335,6 @@
               </a:rPr>
               <a:t>MYSQL 9.7 LTS  |  COMMUNITY SERVER 26.7</a:t>
             </a:r>
-            <a:endParaRPr sz="1000"/>
           </a:p>
         </p:txBody>
       </p:sp>
@@ -11514,7 +11385,6 @@
               </a:rPr>
               <a:t>Looking forward</a:t>
             </a:r>
-            <a:endParaRPr sz="1000"/>
           </a:p>
         </p:txBody>
       </p:sp>
@@ -11565,7 +11435,6 @@
               </a:rPr>
               <a:t>18</a:t>
             </a:r>
-            <a:endParaRPr sz="1200"/>
           </a:p>
         </p:txBody>
       </p:sp>
@@ -11645,7 +11514,6 @@
               </a:rPr>
               <a:t>SESSION TAKEAWAYS</a:t>
             </a:r>
-            <a:endParaRPr sz="1100"/>
           </a:p>
         </p:txBody>
       </p:sp>
@@ -11696,7 +11564,6 @@
               </a:rPr>
               <a:t>Best features to explore after this session</a:t>
             </a:r>
-            <a:endParaRPr sz="2600"/>
           </a:p>
         </p:txBody>
       </p:sp>
@@ -11807,7 +11674,6 @@
               </a:rPr>
               <a:t>On 9.7 LTS</a:t>
             </a:r>
-            <a:endParaRPr sz="2000"/>
           </a:p>
         </p:txBody>
       </p:sp>
@@ -11840,7 +11706,6 @@
           <a:lstStyle xmlns:a="http://schemas.openxmlformats.org/drawingml/2006/main"/>
           <a:p xmlns:a="http://schemas.openxmlformats.org/drawingml/2006/main">
             <a:pPr marL="342900" indent="-342900">
-              <a:buSzPct val="100000"/>
               <a:buChar char="•"/>
               <a:defRPr>
                 <a:solidFill>
@@ -11859,11 +11724,9 @@
               </a:rPr>
               <a:t>Writable JSON Duality View on one real schema</a:t>
             </a:r>
-            <a:endParaRPr sz="1600"/>
           </a:p>
           <a:p xmlns:a="http://schemas.openxmlformats.org/drawingml/2006/main">
             <a:pPr marL="342900" indent="-342900">
-              <a:buSzPct val="100000"/>
               <a:buChar char="•"/>
               <a:defRPr>
                 <a:solidFill>
@@ -11882,11 +11745,9 @@
               </a:rPr>
               <a:t>Hypergraph vs classical EXPLAIN ANALYZE</a:t>
             </a:r>
-            <a:endParaRPr sz="1600"/>
           </a:p>
           <a:p xmlns:a="http://schemas.openxmlformats.org/drawingml/2006/main">
             <a:pPr marL="342900" indent="-342900">
-              <a:buSzPct val="100000"/>
               <a:buChar char="•"/>
               <a:defRPr>
                 <a:solidFill>
@@ -11905,11 +11766,9 @@
               </a:rPr>
               <a:t>Enable GR metrics + flow-control stats</a:t>
             </a:r>
-            <a:endParaRPr sz="1600"/>
           </a:p>
           <a:p xmlns:a="http://schemas.openxmlformats.org/drawingml/2006/main">
             <a:pPr marL="342900" indent="-342900">
-              <a:buSzPct val="100000"/>
               <a:buChar char="•"/>
               <a:defRPr>
                 <a:solidFill>
@@ -11928,7 +11787,6 @@
               </a:rPr>
               <a:t>Wire OTel to your existing collector</a:t>
             </a:r>
-            <a:endParaRPr sz="1600"/>
           </a:p>
         </p:txBody>
       </p:sp>
@@ -12039,7 +11897,6 @@
               </a:rPr>
               <a:t>On 26.7 lab</a:t>
             </a:r>
-            <a:endParaRPr sz="2000"/>
           </a:p>
         </p:txBody>
       </p:sp>
@@ -12072,7 +11929,6 @@
           <a:lstStyle xmlns:a="http://schemas.openxmlformats.org/drawingml/2006/main"/>
           <a:p xmlns:a="http://schemas.openxmlformats.org/drawingml/2006/main">
             <a:pPr marL="342900" indent="-342900">
-              <a:buSzPct val="100000"/>
               <a:buChar char="•"/>
               <a:defRPr>
                 <a:solidFill>
@@ -12091,11 +11947,9 @@
               </a:rPr>
               <a:t>CSA on one replica channel (APPLIER_VERSION=2)</a:t>
             </a:r>
-            <a:endParaRPr sz="1600"/>
           </a:p>
           <a:p xmlns:a="http://schemas.openxmlformats.org/drawingml/2006/main">
             <a:pPr marL="342900" indent="-342900">
-              <a:buSzPct val="100000"/>
               <a:buChar char="•"/>
               <a:defRPr>
                 <a:solidFill>
@@ -12114,11 +11968,9 @@
               </a:rPr>
               <a:t>Thread Pool under a connection storm</a:t>
             </a:r>
-            <a:endParaRPr sz="1600"/>
           </a:p>
           <a:p xmlns:a="http://schemas.openxmlformats.org/drawingml/2006/main">
             <a:pPr marL="342900" indent="-342900">
-              <a:buSzPct val="100000"/>
               <a:buChar char="•"/>
               <a:defRPr>
                 <a:solidFill>
@@ -12137,11 +11989,9 @@
               </a:rPr>
               <a:t>Inventory XCom options before GR default change</a:t>
             </a:r>
-            <a:endParaRPr sz="1600"/>
           </a:p>
           <a:p xmlns:a="http://schemas.openxmlformats.org/drawingml/2006/main">
             <a:pPr marL="342900" indent="-342900">
-              <a:buSzPct val="100000"/>
               <a:buChar char="•"/>
               <a:defRPr>
                 <a:solidFill>
@@ -12160,7 +12010,6 @@
               </a:rPr>
               <a:t>Run upgrade checker and watch progress output</a:t>
             </a:r>
-            <a:endParaRPr sz="1600"/>
           </a:p>
         </p:txBody>
       </p:sp>
@@ -12238,7 +12087,6 @@
               </a:rPr>
               <a:t>MYSQL 9.7 LTS  |  COMMUNITY SERVER 26.7</a:t>
             </a:r>
-            <a:endParaRPr sz="1000"/>
           </a:p>
         </p:txBody>
       </p:sp>
@@ -12289,7 +12137,6 @@
               </a:rPr>
               <a:t>Explore next</a:t>
             </a:r>
-            <a:endParaRPr sz="1000"/>
           </a:p>
         </p:txBody>
       </p:sp>
@@ -12340,7 +12187,6 @@
               </a:rPr>
               <a:t>19</a:t>
             </a:r>
-            <a:endParaRPr sz="1200"/>
           </a:p>
         </p:txBody>
       </p:sp>
@@ -12420,7 +12266,6 @@
               </a:rPr>
               <a:t>AGENDA</a:t>
             </a:r>
-            <a:endParaRPr sz="1100"/>
           </a:p>
         </p:txBody>
       </p:sp>
@@ -12471,7 +12316,6 @@
               </a:rPr>
               <a:t>What we will cover today</a:t>
             </a:r>
-            <a:endParaRPr sz="2800"/>
           </a:p>
         </p:txBody>
       </p:sp>
@@ -12555,7 +12399,6 @@
               </a:rPr>
               <a:t>01</a:t>
             </a:r>
-            <a:endParaRPr sz="2200"/>
           </a:p>
         </p:txBody>
       </p:sp>
@@ -12606,7 +12449,6 @@
               </a:rPr>
               <a:t>The two-track model</a:t>
             </a:r>
-            <a:endParaRPr sz="1800"/>
           </a:p>
         </p:txBody>
       </p:sp>
@@ -12657,7 +12499,6 @@
               </a:rPr>
               <a:t>LTS vs Innovation, calendar versioning, and why 9.7 + 26.7 both matter</a:t>
             </a:r>
-            <a:endParaRPr sz="1400"/>
           </a:p>
         </p:txBody>
       </p:sp>
@@ -12741,7 +12582,6 @@
               </a:rPr>
               <a:t>02</a:t>
             </a:r>
-            <a:endParaRPr sz="2200"/>
           </a:p>
         </p:txBody>
       </p:sp>
@@ -12792,7 +12632,6 @@
               </a:rPr>
               <a:t>MySQL 9.7 LTS highlights</a:t>
             </a:r>
-            <a:endParaRPr sz="1800"/>
           </a:p>
         </p:txBody>
       </p:sp>
@@ -12843,7 +12682,6 @@
               </a:rPr>
               <a:t>Community expansion, JSON Duality Views, Hypergraph Optimizer, GR, telemetry</a:t>
             </a:r>
-            <a:endParaRPr sz="1400"/>
           </a:p>
         </p:txBody>
       </p:sp>
@@ -12927,7 +12765,6 @@
               </a:rPr>
               <a:t>03</a:t>
             </a:r>
-            <a:endParaRPr sz="2200"/>
           </a:p>
         </p:txBody>
       </p:sp>
@@ -12978,7 +12815,6 @@
               </a:rPr>
               <a:t>JSON Duality Views in depth</a:t>
             </a:r>
-            <a:endParaRPr sz="1800"/>
           </a:p>
         </p:txBody>
       </p:sp>
@@ -13029,7 +12865,6 @@
               </a:rPr>
               <a:t>Why they matter, how writes work, and where to apply them</a:t>
             </a:r>
-            <a:endParaRPr sz="1400"/>
           </a:p>
         </p:txBody>
       </p:sp>
@@ -13113,7 +12948,6 @@
               </a:rPr>
               <a:t>04</a:t>
             </a:r>
-            <a:endParaRPr sz="2200"/>
           </a:p>
         </p:txBody>
       </p:sp>
@@ -13164,7 +12998,6 @@
               </a:rPr>
               <a:t>MySQL 26.7 Innovation highlights</a:t>
             </a:r>
-            <a:endParaRPr sz="1800"/>
           </a:p>
         </p:txBody>
       </p:sp>
@@ -13215,7 +13048,6 @@
               </a:rPr>
               <a:t>Change Stream Applier, Thread Pool, MYSQL GR stack, InnoDB, PQC</a:t>
             </a:r>
-            <a:endParaRPr sz="1400"/>
           </a:p>
         </p:txBody>
       </p:sp>
@@ -13299,7 +13131,6 @@
               </a:rPr>
               <a:t>05</a:t>
             </a:r>
-            <a:endParaRPr sz="2200"/>
           </a:p>
         </p:txBody>
       </p:sp>
@@ -13350,7 +13181,6 @@
               </a:rPr>
               <a:t>What to explore next</a:t>
             </a:r>
-            <a:endParaRPr sz="1800"/>
           </a:p>
         </p:txBody>
       </p:sp>
@@ -13401,7 +13231,6 @@
               </a:rPr>
               <a:t>Track choice, test plan, Enterprise extras, and the road to 26.10</a:t>
             </a:r>
-            <a:endParaRPr sz="1400"/>
           </a:p>
         </p:txBody>
       </p:sp>
@@ -13479,7 +13308,6 @@
               </a:rPr>
               <a:t>MYSQL 9.7 LTS  |  COMMUNITY SERVER 26.7</a:t>
             </a:r>
-            <a:endParaRPr sz="1000"/>
           </a:p>
         </p:txBody>
       </p:sp>
@@ -13530,7 +13358,6 @@
               </a:rPr>
               <a:t>Agenda</a:t>
             </a:r>
-            <a:endParaRPr sz="1000"/>
           </a:p>
         </p:txBody>
       </p:sp>
@@ -13581,7 +13408,6 @@
               </a:rPr>
               <a:t>02</a:t>
             </a:r>
-            <a:endParaRPr sz="1200"/>
           </a:p>
         </p:txBody>
       </p:sp>
@@ -13723,7 +13549,6 @@
               </a:rPr>
               <a:t>CLOSE</a:t>
             </a:r>
-            <a:endParaRPr sz="1300"/>
           </a:p>
         </p:txBody>
       </p:sp>
@@ -13774,7 +13599,6 @@
               </a:rPr>
               <a:t>9.7 is the floor. 26.7 is the horizon.</a:t>
             </a:r>
-            <a:endParaRPr sz="3200"/>
           </a:p>
         </p:txBody>
       </p:sp>
@@ -13825,7 +13649,6 @@
               </a:rPr>
               <a:t>Standardize production on 9.7 LTS. Lab the Innovation line every quarter. Promote only what your tests prove.</a:t>
             </a:r>
-            <a:endParaRPr sz="1800"/>
           </a:p>
         </p:txBody>
       </p:sp>
@@ -13907,7 +13730,6 @@
               </a:rPr>
               <a:t>dev.mysql.com/doc/relnotes  ·  blogs.oracle.com/mysql</a:t>
             </a:r>
-            <a:endParaRPr sz="1500"/>
           </a:p>
         </p:txBody>
       </p:sp>
@@ -13989,7 +13811,6 @@
               </a:rPr>
               <a:t>QUESTIONS</a:t>
             </a:r>
-            <a:endParaRPr sz="1200"/>
           </a:p>
         </p:txBody>
       </p:sp>
@@ -14102,7 +13923,6 @@
               </a:rPr>
               <a:t>CONTEXT</a:t>
             </a:r>
-            <a:endParaRPr sz="1100"/>
           </a:p>
         </p:txBody>
       </p:sp>
@@ -14153,7 +13973,6 @@
               </a:rPr>
               <a:t>A new baseline, a new versioning model</a:t>
             </a:r>
-            <a:endParaRPr sz="2800"/>
           </a:p>
         </p:txBody>
       </p:sp>
@@ -14264,7 +14083,6 @@
               </a:rPr>
               <a:t>8.0 is EOL</a:t>
             </a:r>
-            <a:endParaRPr sz="2000"/>
           </a:p>
         </p:txBody>
       </p:sp>
@@ -14315,7 +14133,6 @@
               </a:rPr>
               <a:t>MySQL 8.0 reached end of life in April 2026. Teams still on 8.0 need a current, supported LTS target.</a:t>
             </a:r>
-            <a:endParaRPr sz="1500"/>
           </a:p>
         </p:txBody>
       </p:sp>
@@ -14426,7 +14243,6 @@
               </a:rPr>
               <a:t>9.7 is the LTS</a:t>
             </a:r>
-            <a:endParaRPr sz="2000"/>
           </a:p>
         </p:txBody>
       </p:sp>
@@ -14475,9 +14291,8 @@
                 <a:ea typeface="Calibri"/>
                 <a:cs typeface="Calibri"/>
               </a:rPr>
-              <a:t>GA 21 April 2026. Stable feature set, quarterly maintenance (9.7.2 in July, 9.7.3 security in August).</a:t>
-            </a:r>
-            <a:endParaRPr sz="1500"/>
+              <a:t>The latest LTS release, a stable release with bug fixes. GA 21 April 2026; quarterly maintenance.</a:t>
+            </a:r>
           </a:p>
         </p:txBody>
       </p:sp>
@@ -14588,7 +14403,6 @@
               </a:rPr>
               <a:t>26.7 is Innovation</a:t>
             </a:r>
-            <a:endParaRPr sz="2000"/>
           </a:p>
         </p:txBody>
       </p:sp>
@@ -14639,7 +14453,6 @@
               </a:rPr>
               <a:t>First CalVer Innovation GA (28 July 2026). YY.M.P — 26 = 2026, 7 = July. Next window: 26.10.0.</a:t>
             </a:r>
-            <a:endParaRPr sz="1500"/>
           </a:p>
         </p:txBody>
       </p:sp>
@@ -14750,7 +14563,6 @@
               </a:rPr>
               <a:t>Community stronger</a:t>
             </a:r>
-            <a:endParaRPr sz="2000"/>
           </a:p>
         </p:txBody>
       </p:sp>
@@ -14801,7 +14613,6 @@
               </a:rPr>
               <a:t>Multiple former Enterprise capabilities now ship in Community: optimizer, duality DML, GR, telemetry, thread pool.</a:t>
             </a:r>
-            <a:endParaRPr sz="1500"/>
           </a:p>
         </p:txBody>
       </p:sp>
@@ -14879,7 +14690,6 @@
               </a:rPr>
               <a:t>MYSQL 9.7 LTS  |  COMMUNITY SERVER 26.7</a:t>
             </a:r>
-            <a:endParaRPr sz="1000"/>
           </a:p>
         </p:txBody>
       </p:sp>
@@ -14930,7 +14740,6 @@
               </a:rPr>
               <a:t>Context</a:t>
             </a:r>
-            <a:endParaRPr sz="1000"/>
           </a:p>
         </p:txBody>
       </p:sp>
@@ -14981,7 +14790,6 @@
               </a:rPr>
               <a:t>03</a:t>
             </a:r>
-            <a:endParaRPr sz="1200"/>
           </a:p>
         </p:txBody>
       </p:sp>
@@ -15061,7 +14869,6 @@
               </a:rPr>
               <a:t>RELEASE MODEL</a:t>
             </a:r>
-            <a:endParaRPr sz="1100"/>
           </a:p>
         </p:txBody>
       </p:sp>
@@ -15112,7 +14919,6 @@
               </a:rPr>
               <a:t>Choose the track that matches how you operate</a:t>
             </a:r>
-            <a:endParaRPr sz="2600"/>
           </a:p>
         </p:txBody>
       </p:sp>
@@ -15196,7 +15002,6 @@
               </a:rPr>
               <a:t>LONG-TERM SUPPORT</a:t>
             </a:r>
-            <a:endParaRPr sz="1200"/>
           </a:p>
         </p:txBody>
       </p:sp>
@@ -15247,7 +15052,6 @@
               </a:rPr>
               <a:t>MySQL 9.7.x</a:t>
             </a:r>
-            <a:endParaRPr sz="2800"/>
           </a:p>
         </p:txBody>
       </p:sp>
@@ -15280,7 +15084,6 @@
           <a:lstStyle xmlns:a="http://schemas.openxmlformats.org/drawingml/2006/main"/>
           <a:p xmlns:a="http://schemas.openxmlformats.org/drawingml/2006/main">
             <a:pPr marL="342900" indent="-342900">
-              <a:buSzPct val="100000"/>
               <a:buChar char="•"/>
               <a:defRPr>
                 <a:solidFill>
@@ -15299,11 +15102,9 @@
               </a:rPr>
               <a:t>Stable feature set for the life of the series</a:t>
             </a:r>
-            <a:endParaRPr sz="1500"/>
           </a:p>
           <a:p xmlns:a="http://schemas.openxmlformats.org/drawingml/2006/main">
             <a:pPr marL="342900" indent="-342900">
-              <a:buSzPct val="100000"/>
               <a:buChar char="•"/>
               <a:defRPr>
                 <a:solidFill>
@@ -15322,11 +15123,9 @@
               </a:rPr>
               <a:t>Quarterly bug + security maintenance</a:t>
             </a:r>
-            <a:endParaRPr sz="1500"/>
           </a:p>
           <a:p xmlns:a="http://schemas.openxmlformats.org/drawingml/2006/main">
             <a:pPr marL="342900" indent="-342900">
-              <a:buSzPct val="100000"/>
               <a:buChar char="•"/>
               <a:defRPr>
                 <a:solidFill>
@@ -15345,11 +15144,9 @@
               </a:rPr>
               <a:t>In-place upgrades within the LTS line</a:t>
             </a:r>
-            <a:endParaRPr sz="1500"/>
           </a:p>
           <a:p xmlns:a="http://schemas.openxmlformats.org/drawingml/2006/main">
             <a:pPr marL="342900" indent="-342900">
-              <a:buSzPct val="100000"/>
               <a:buChar char="•"/>
               <a:defRPr>
                 <a:solidFill>
@@ -15368,11 +15165,9 @@
               </a:rPr>
               <a:t>Best for production standardization</a:t>
             </a:r>
-            <a:endParaRPr sz="1500"/>
           </a:p>
           <a:p xmlns:a="http://schemas.openxmlformats.org/drawingml/2006/main">
             <a:pPr marL="342900" indent="-342900">
-              <a:buSzPct val="100000"/>
               <a:buChar char="•"/>
               <a:defRPr>
                 <a:solidFill>
@@ -15391,7 +15186,6 @@
               </a:rPr>
               <a:t>Current patch: 9.7.2 / 9.7.3 (CSPU)</a:t>
             </a:r>
-            <a:endParaRPr sz="1500"/>
           </a:p>
         </p:txBody>
       </p:sp>
@@ -15475,7 +15269,6 @@
               </a:rPr>
               <a:t>INNOVATION  ·  CALVER YY.MM</a:t>
             </a:r>
-            <a:endParaRPr sz="1200"/>
           </a:p>
         </p:txBody>
       </p:sp>
@@ -15526,7 +15319,6 @@
               </a:rPr>
               <a:t>MySQL 26.7</a:t>
             </a:r>
-            <a:endParaRPr sz="2800"/>
           </a:p>
         </p:txBody>
       </p:sp>
@@ -15559,7 +15351,6 @@
           <a:lstStyle xmlns:a="http://schemas.openxmlformats.org/drawingml/2006/main"/>
           <a:p xmlns:a="http://schemas.openxmlformats.org/drawingml/2006/main">
             <a:pPr marL="342900" indent="-342900">
-              <a:buSzPct val="100000"/>
               <a:buChar char="•"/>
               <a:defRPr>
                 <a:solidFill>
@@ -15578,11 +15369,9 @@
               </a:rPr>
               <a:t>Newest features every quarter</a:t>
             </a:r>
-            <a:endParaRPr sz="1500"/>
           </a:p>
           <a:p xmlns:a="http://schemas.openxmlformats.org/drawingml/2006/main">
             <a:pPr marL="342900" indent="-342900">
-              <a:buSzPct val="100000"/>
               <a:buChar char="•"/>
               <a:defRPr>
                 <a:solidFill>
@@ -15601,11 +15390,9 @@
               </a:rPr>
               <a:t>Deprecations and removals land here first</a:t>
             </a:r>
-            <a:endParaRPr sz="1500"/>
           </a:p>
           <a:p xmlns:a="http://schemas.openxmlformats.org/drawingml/2006/main">
             <a:pPr marL="342900" indent="-342900">
-              <a:buSzPct val="100000"/>
               <a:buChar char="•"/>
               <a:defRPr>
                 <a:solidFill>
@@ -15624,11 +15411,9 @@
               </a:rPr>
               <a:t>Production-grade, but expect more change</a:t>
             </a:r>
-            <a:endParaRPr sz="1500"/>
           </a:p>
           <a:p xmlns:a="http://schemas.openxmlformats.org/drawingml/2006/main">
             <a:pPr marL="342900" indent="-342900">
-              <a:buSzPct val="100000"/>
               <a:buChar char="•"/>
               <a:defRPr>
                 <a:solidFill>
@@ -15647,11 +15432,9 @@
               </a:rPr>
               <a:t>Best for teams that can test and upgrade often</a:t>
             </a:r>
-            <a:endParaRPr sz="1500"/>
           </a:p>
           <a:p xmlns:a="http://schemas.openxmlformats.org/drawingml/2006/main">
             <a:pPr marL="342900" indent="-342900">
-              <a:buSzPct val="100000"/>
               <a:buChar char="•"/>
               <a:defRPr>
                 <a:solidFill>
@@ -15670,7 +15453,6 @@
               </a:rPr>
               <a:t>Next scheduled: 26.10.0 (October 2026)</a:t>
             </a:r>
-            <a:endParaRPr sz="1500"/>
           </a:p>
         </p:txBody>
       </p:sp>
@@ -15748,7 +15530,6 @@
               </a:rPr>
               <a:t>MYSQL 9.7 LTS  |  COMMUNITY SERVER 26.7</a:t>
             </a:r>
-            <a:endParaRPr sz="1000"/>
           </a:p>
         </p:txBody>
       </p:sp>
@@ -15799,7 +15580,6 @@
               </a:rPr>
               <a:t>Release model</a:t>
             </a:r>
-            <a:endParaRPr sz="1000"/>
           </a:p>
         </p:txBody>
       </p:sp>
@@ -15850,7 +15630,6 @@
               </a:rPr>
               <a:t>04</a:t>
             </a:r>
-            <a:endParaRPr sz="1200"/>
           </a:p>
         </p:txBody>
       </p:sp>
@@ -15930,7 +15709,6 @@
               </a:rPr>
               <a:t>MYSQL 9.7 LTS</a:t>
             </a:r>
-            <a:endParaRPr sz="1100"/>
           </a:p>
         </p:txBody>
       </p:sp>
@@ -15981,7 +15759,6 @@
               </a:rPr>
               <a:t>Four pillars of Community expansion</a:t>
             </a:r>
-            <a:endParaRPr sz="2600"/>
           </a:p>
         </p:txBody>
       </p:sp>
@@ -16092,7 +15869,6 @@
               </a:rPr>
               <a:t>01</a:t>
             </a:r>
-            <a:endParaRPr sz="2800"/>
           </a:p>
         </p:txBody>
       </p:sp>
@@ -16143,7 +15919,6 @@
               </a:rPr>
               <a:t>Replication &amp; HA</a:t>
             </a:r>
-            <a:endParaRPr sz="1800"/>
           </a:p>
         </p:txBody>
       </p:sp>
@@ -16194,7 +15969,6 @@
               </a:rPr>
               <a:t>Applier metrics, GR flow-control stats, resource manager (evict/rejoin), up-to-date primary election.</a:t>
             </a:r>
-            <a:endParaRPr sz="1400"/>
           </a:p>
         </p:txBody>
       </p:sp>
@@ -16305,7 +16079,6 @@
               </a:rPr>
               <a:t>02</a:t>
             </a:r>
-            <a:endParaRPr sz="2800"/>
           </a:p>
         </p:txBody>
       </p:sp>
@@ -16356,7 +16129,6 @@
               </a:rPr>
               <a:t>Telemetry</a:t>
             </a:r>
-            <a:endParaRPr sz="1800"/>
           </a:p>
         </p:txBody>
       </p:sp>
@@ -16407,7 +16179,6 @@
               </a:rPr>
               <a:t>OpenTelemetry / OTLP export of logs, metrics, and traces. Component-based, pipeline-ready.</a:t>
             </a:r>
-            <a:endParaRPr sz="1400"/>
           </a:p>
         </p:txBody>
       </p:sp>
@@ -16518,7 +16289,6 @@
               </a:rPr>
               <a:t>03</a:t>
             </a:r>
-            <a:endParaRPr sz="2800"/>
           </a:p>
         </p:txBody>
       </p:sp>
@@ -16569,7 +16339,6 @@
               </a:rPr>
               <a:t>Application model</a:t>
             </a:r>
-            <a:endParaRPr sz="1800"/>
           </a:p>
         </p:txBody>
       </p:sp>
@@ -16620,7 +16389,6 @@
               </a:rPr>
               <a:t>JSON Duality Views with full DML in Community — insert, update, delete documents over relational rows.</a:t>
             </a:r>
-            <a:endParaRPr sz="1400"/>
           </a:p>
         </p:txBody>
       </p:sp>
@@ -16731,7 +16499,6 @@
               </a:rPr>
               <a:t>04</a:t>
             </a:r>
-            <a:endParaRPr sz="2800"/>
           </a:p>
         </p:txBody>
       </p:sp>
@@ -16782,7 +16549,6 @@
               </a:rPr>
               <a:t>Query performance</a:t>
             </a:r>
-            <a:endParaRPr sz="1800"/>
           </a:p>
         </p:txBody>
       </p:sp>
@@ -16833,7 +16599,6 @@
               </a:rPr>
               <a:t>Hypergraph Optimizer in Community. Profile-Guided Optimization builds on selected platforms.</a:t>
             </a:r>
-            <a:endParaRPr sz="1400"/>
           </a:p>
         </p:txBody>
       </p:sp>
@@ -16911,7 +16676,6 @@
               </a:rPr>
               <a:t>MYSQL 9.7 LTS  |  COMMUNITY SERVER 26.7</a:t>
             </a:r>
-            <a:endParaRPr sz="1000"/>
           </a:p>
         </p:txBody>
       </p:sp>
@@ -16962,7 +16726,6 @@
               </a:rPr>
               <a:t>9.7 Community</a:t>
             </a:r>
-            <a:endParaRPr sz="1000"/>
           </a:p>
         </p:txBody>
       </p:sp>
@@ -17013,7 +16776,6 @@
               </a:rPr>
               <a:t>05</a:t>
             </a:r>
-            <a:endParaRPr sz="1200"/>
           </a:p>
         </p:txBody>
       </p:sp>
@@ -17093,7 +16855,6 @@
               </a:rPr>
               <a:t>JSON DUALITY VIEWS</a:t>
             </a:r>
-            <a:endParaRPr sz="1100"/>
           </a:p>
         </p:txBody>
       </p:sp>
@@ -17144,7 +16905,6 @@
               </a:rPr>
               <a:t>Same data. Two interfaces. One stored copy.</a:t>
             </a:r>
-            <a:endParaRPr sz="2600"/>
           </a:p>
         </p:txBody>
       </p:sp>
@@ -17228,7 +16988,6 @@
               </a:rPr>
               <a:t>A duality view projects related tables as a hierarchical JSON document. Apps read and write that document. MySQL keeps the rows normalized — keys, FKs, types, and indexes stay on the tables. No second copy to sync.</a:t>
             </a:r>
-            <a:endParaRPr sz="1600"/>
           </a:p>
         </p:txBody>
       </p:sp>
@@ -17312,7 +17071,6 @@
               </a:rPr>
               <a:t>Tables</a:t>
             </a:r>
-            <a:endParaRPr sz="2000"/>
           </a:p>
         </p:txBody>
       </p:sp>
@@ -17363,7 +17121,6 @@
               </a:rPr>
               <a:t>Reporting, ETL, HeatWave, constraints</a:t>
             </a:r>
-            <a:endParaRPr sz="1400"/>
           </a:p>
         </p:txBody>
       </p:sp>
@@ -17414,7 +17171,6 @@
               </a:rPr>
               <a:t>customers  ·  orders  ·  order_items</a:t>
             </a:r>
-            <a:endParaRPr sz="1600"/>
           </a:p>
         </p:txBody>
       </p:sp>
@@ -17498,7 +17254,6 @@
               </a:rPr>
               <a:t>Duality view</a:t>
             </a:r>
-            <a:endParaRPr sz="2000"/>
           </a:p>
         </p:txBody>
       </p:sp>
@@ -17549,7 +17304,6 @@
               </a:rPr>
               <a:t>APIs, SPAs, mobile, microservices</a:t>
             </a:r>
-            <a:endParaRPr sz="1400"/>
           </a:p>
         </p:txBody>
       </p:sp>
@@ -17600,7 +17354,6 @@
               </a:rPr>
               <a:t>{ customer, orders: [ … ] }</a:t>
             </a:r>
-            <a:endParaRPr sz="1600"/>
           </a:p>
         </p:txBody>
       </p:sp>
@@ -17651,7 +17404,6 @@
               </a:rPr>
               <a:t>9.7 Community change: views were readable before; INSERT, UPDATE, DELETE and auto-increment propagation now ship in Community, not only Enterprise.</a:t>
             </a:r>
-            <a:endParaRPr sz="1500"/>
           </a:p>
         </p:txBody>
       </p:sp>
@@ -17729,7 +17481,6 @@
               </a:rPr>
               <a:t>MYSQL 9.7 LTS  |  COMMUNITY SERVER 26.7</a:t>
             </a:r>
-            <a:endParaRPr sz="1000"/>
           </a:p>
         </p:txBody>
       </p:sp>
@@ -17780,7 +17531,6 @@
               </a:rPr>
               <a:t>Duality — what it is</a:t>
             </a:r>
-            <a:endParaRPr sz="1000"/>
           </a:p>
         </p:txBody>
       </p:sp>
@@ -17831,7 +17581,6 @@
               </a:rPr>
               <a:t>06</a:t>
             </a:r>
-            <a:endParaRPr sz="1200"/>
           </a:p>
         </p:txBody>
       </p:sp>
@@ -17911,7 +17660,6 @@
               </a:rPr>
               <a:t>JSON DUALITY VIEWS</a:t>
             </a:r>
-            <a:endParaRPr sz="1100"/>
           </a:p>
         </p:txBody>
       </p:sp>
@@ -17962,7 +17710,6 @@
               </a:rPr>
               <a:t>Why it matters: stop writing JSON plumbing</a:t>
             </a:r>
-            <a:endParaRPr sz="2400"/>
           </a:p>
         </p:txBody>
       </p:sp>
@@ -18046,7 +17793,6 @@
               </a:rPr>
               <a:t>THE OLD PATH</a:t>
             </a:r>
-            <a:endParaRPr sz="1200"/>
           </a:p>
         </p:txBody>
       </p:sp>
@@ -18079,7 +17825,6 @@
           <a:lstStyle xmlns:a="http://schemas.openxmlformats.org/drawingml/2006/main"/>
           <a:p xmlns:a="http://schemas.openxmlformats.org/drawingml/2006/main">
             <a:pPr marL="342900" indent="-342900">
-              <a:buSzPct val="100000"/>
               <a:buChar char="•"/>
               <a:defRPr>
                 <a:solidFill>
@@ -18098,11 +17843,9 @@
               </a:rPr>
               <a:t>SELECT parent, then children</a:t>
             </a:r>
-            <a:endParaRPr sz="1600"/>
           </a:p>
           <a:p xmlns:a="http://schemas.openxmlformats.org/drawingml/2006/main">
             <a:pPr marL="342900" indent="-342900">
-              <a:buSzPct val="100000"/>
               <a:buChar char="•"/>
               <a:defRPr>
                 <a:solidFill>
@@ -18121,11 +17864,9 @@
               </a:rPr>
               <a:t>Assemble JSON in the application</a:t>
             </a:r>
-            <a:endParaRPr sz="1600"/>
           </a:p>
           <a:p xmlns:a="http://schemas.openxmlformats.org/drawingml/2006/main">
             <a:pPr marL="342900" indent="-342900">
-              <a:buSzPct val="100000"/>
               <a:buChar char="•"/>
               <a:defRPr>
                 <a:solidFill>
@@ -18144,11 +17885,9 @@
               </a:rPr>
               <a:t>On write: split the payload</a:t>
             </a:r>
-            <a:endParaRPr sz="1600"/>
           </a:p>
           <a:p xmlns:a="http://schemas.openxmlformats.org/drawingml/2006/main">
             <a:pPr marL="342900" indent="-342900">
-              <a:buSzPct val="100000"/>
               <a:buChar char="•"/>
               <a:defRPr>
                 <a:solidFill>
@@ -18167,11 +17906,9 @@
               </a:rPr>
               <a:t>Open a transaction; DML N tables in order</a:t>
             </a:r>
-            <a:endParaRPr sz="1600"/>
           </a:p>
           <a:p xmlns:a="http://schemas.openxmlformats.org/drawingml/2006/main">
             <a:pPr marL="342900" indent="-342900">
-              <a:buSzPct val="100000"/>
               <a:buChar char="•"/>
               <a:defRPr>
                 <a:solidFill>
@@ -18190,7 +17927,6 @@
               </a:rPr>
               <a:t>Hope FKs and concurrency stay consistent</a:t>
             </a:r>
-            <a:endParaRPr sz="1600"/>
           </a:p>
         </p:txBody>
       </p:sp>
@@ -18274,7 +18010,6 @@
               </a:rPr>
               <a:t>WHAT THE SERVER NOW OWNS</a:t>
             </a:r>
-            <a:endParaRPr sz="1200"/>
           </a:p>
         </p:txBody>
       </p:sp>
@@ -18307,7 +18042,6 @@
           <a:lstStyle xmlns:a="http://schemas.openxmlformats.org/drawingml/2006/main"/>
           <a:p xmlns:a="http://schemas.openxmlformats.org/drawingml/2006/main">
             <a:pPr marL="342900" indent="-342900">
-              <a:buSzPct val="100000"/>
               <a:buChar char="•"/>
               <a:defRPr>
                 <a:solidFill>
@@ -18326,11 +18060,9 @@
               </a:rPr>
               <a:t>One atomic document write across tables</a:t>
             </a:r>
-            <a:endParaRPr sz="1600"/>
           </a:p>
           <a:p xmlns:a="http://schemas.openxmlformats.org/drawingml/2006/main">
             <a:pPr marL="342900" indent="-342900">
-              <a:buSzPct val="100000"/>
               <a:buChar char="•"/>
               <a:defRPr>
                 <a:solidFill>
@@ -18349,11 +18081,9 @@
               </a:rPr>
               <a:t>Schema still wins — types, PKs, FKs, CHECKs</a:t>
             </a:r>
-            <a:endParaRPr sz="1600"/>
           </a:p>
           <a:p xmlns:a="http://schemas.openxmlformats.org/drawingml/2006/main">
             <a:pPr marL="342900" indent="-342900">
-              <a:buSzPct val="100000"/>
               <a:buChar char="•"/>
               <a:defRPr>
                 <a:solidFill>
@@ -18372,11 +18102,9 @@
               </a:rPr>
               <a:t>No denormalized JSON copy to keep in sync</a:t>
             </a:r>
-            <a:endParaRPr sz="1600"/>
           </a:p>
           <a:p xmlns:a="http://schemas.openxmlformats.org/drawingml/2006/main">
             <a:pPr marL="342900" indent="-342900">
-              <a:buSzPct val="100000"/>
               <a:buChar char="•"/>
               <a:defRPr>
                 <a:solidFill>
@@ -18395,11 +18123,9 @@
               </a:rPr>
               <a:t>Lockless etag concurrency for REST-style calls</a:t>
             </a:r>
-            <a:endParaRPr sz="1600"/>
           </a:p>
           <a:p xmlns:a="http://schemas.openxmlformats.org/drawingml/2006/main">
             <a:pPr marL="342900" indent="-342900">
-              <a:buSzPct val="100000"/>
               <a:buChar char="•"/>
               <a:defRPr>
                 <a:solidFill>
@@ -18418,7 +18144,6 @@
               </a:rPr>
               <a:t>WITH(INSERT, UPDATE, DELETE) per nested object</a:t>
             </a:r>
-            <a:endParaRPr sz="1600"/>
           </a:p>
         </p:txBody>
       </p:sp>
@@ -18496,7 +18221,6 @@
               </a:rPr>
               <a:t>MYSQL 9.7 LTS  |  COMMUNITY SERVER 26.7</a:t>
             </a:r>
-            <a:endParaRPr sz="1000"/>
           </a:p>
         </p:txBody>
       </p:sp>
@@ -18547,7 +18271,6 @@
               </a:rPr>
               <a:t>Duality — why it matters</a:t>
             </a:r>
-            <a:endParaRPr sz="1000"/>
           </a:p>
         </p:txBody>
       </p:sp>
@@ -18598,7 +18321,6 @@
               </a:rPr>
               <a:t>07</a:t>
             </a:r>
-            <a:endParaRPr sz="1200"/>
           </a:p>
         </p:txBody>
       </p:sp>
@@ -18678,7 +18400,6 @@
               </a:rPr>
               <a:t>JSON DUALITY VIEWS</a:t>
             </a:r>
-            <a:endParaRPr sz="1100"/>
           </a:p>
         </p:txBody>
       </p:sp>
@@ -18729,7 +18450,6 @@
               </a:rPr>
               <a:t>How a document write actually runs</a:t>
             </a:r>
-            <a:endParaRPr sz="2600"/>
           </a:p>
         </p:txBody>
       </p:sp>
@@ -18813,7 +18533,6 @@
               </a:rPr>
               <a:t>1</a:t>
             </a:r>
-            <a:endParaRPr sz="2200"/>
           </a:p>
         </p:txBody>
       </p:sp>
@@ -18864,7 +18583,6 @@
               </a:rPr>
               <a:t>Validate</a:t>
             </a:r>
-            <a:endParaRPr sz="1600"/>
           </a:p>
         </p:txBody>
       </p:sp>
@@ -18915,7 +18633,6 @@
               </a:rPr>
               <a:t>Incoming JSON must match the view shape.</a:t>
             </a:r>
-            <a:endParaRPr sz="1300"/>
           </a:p>
         </p:txBody>
       </p:sp>
@@ -18999,7 +18716,6 @@
               </a:rPr>
               <a:t>2</a:t>
             </a:r>
-            <a:endParaRPr sz="2200"/>
           </a:p>
         </p:txBody>
       </p:sp>
@@ -19050,7 +18766,6 @@
               </a:rPr>
               <a:t>Map types</a:t>
             </a:r>
-            <a:endParaRPr sz="1600"/>
           </a:p>
         </p:txBody>
       </p:sp>
@@ -19101,7 +18816,6 @@
               </a:rPr>
               <a:t>JSON values map onto column types.</a:t>
             </a:r>
-            <a:endParaRPr sz="1300"/>
           </a:p>
         </p:txBody>
       </p:sp>
@@ -19185,7 +18899,6 @@
               </a:rPr>
               <a:t>3</a:t>
             </a:r>
-            <a:endParaRPr sz="2200"/>
           </a:p>
         </p:txBody>
       </p:sp>
@@ -19236,7 +18949,6 @@
               </a:rPr>
               <a:t>Generate DML</a:t>
             </a:r>
-            <a:endParaRPr sz="1600"/>
           </a:p>
         </p:txBody>
       </p:sp>
@@ -19287,7 +18999,6 @@
               </a:rPr>
               <a:t>Parent then children — or reverse on delete.</a:t>
             </a:r>
-            <a:endParaRPr sz="1300"/>
           </a:p>
         </p:txBody>
       </p:sp>
@@ -19371,7 +19082,6 @@
               </a:rPr>
               <a:t>4</a:t>
             </a:r>
-            <a:endParaRPr sz="2200"/>
           </a:p>
         </p:txBody>
       </p:sp>
@@ -19422,7 +19132,6 @@
               </a:rPr>
               <a:t>Execute</a:t>
             </a:r>
-            <a:endParaRPr sz="1600"/>
           </a:p>
         </p:txBody>
       </p:sp>
@@ -19473,7 +19182,6 @@
               </a:rPr>
               <a:t>Sub-statements run as one atomic operation.</a:t>
             </a:r>
-            <a:endParaRPr sz="1300"/>
           </a:p>
         </p:txBody>
       </p:sp>
@@ -19557,7 +19265,6 @@
               </a:rPr>
               <a:t>5</a:t>
             </a:r>
-            <a:endParaRPr sz="2200"/>
           </a:p>
         </p:txBody>
       </p:sp>
@@ -19608,7 +19315,6 @@
               </a:rPr>
               <a:t>Check etag</a:t>
             </a:r>
-            <a:endParaRPr sz="1600"/>
           </a:p>
         </p:txBody>
       </p:sp>
@@ -19659,7 +19365,6 @@
               </a:rPr>
               <a:t>Updates fail if the document changed since read.</a:t>
             </a:r>
-            <a:endParaRPr sz="1300"/>
           </a:p>
         </p:txBody>
       </p:sp>
@@ -19743,7 +19448,6 @@
               </a:rPr>
               <a:t>SHAPE OF A TYPICAL VIEW</a:t>
             </a:r>
-            <a:endParaRPr sz="1200"/>
           </a:p>
         </p:txBody>
       </p:sp>
@@ -19794,7 +19498,6 @@
               </a:rPr>
               <a:t>CREATE JSON DUALITY VIEW customer_orders_dv AS  SELECT JSON_DUALITY_OBJECT(WITH(INSERT,UPDATE,DELETE)  '_id': customer_id, 'name': name,  'orders': (SELECT JSON_ARRAYAGG(JSON_DUALITY_OBJECT(WITH(INSERT,UPDATE,DELETE) …)) FROM orders WHERE …) ) FROM customers;</a:t>
             </a:r>
-            <a:endParaRPr sz="1400"/>
           </a:p>
         </p:txBody>
       </p:sp>
@@ -19845,7 +19548,6 @@
               </a:rPr>
               <a:t>Then INSERT a JSON document into the view. MySQL writes customers and orders. You never issue those two INSERTs yourself.</a:t>
             </a:r>
-            <a:endParaRPr sz="1400"/>
           </a:p>
         </p:txBody>
       </p:sp>
@@ -19923,7 +19625,6 @@
               </a:rPr>
               <a:t>MYSQL 9.7 LTS  |  COMMUNITY SERVER 26.7</a:t>
             </a:r>
-            <a:endParaRPr sz="1000"/>
           </a:p>
         </p:txBody>
       </p:sp>
@@ -19974,7 +19675,6 @@
               </a:rPr>
               <a:t>Duality — how writes work</a:t>
             </a:r>
-            <a:endParaRPr sz="1000"/>
           </a:p>
         </p:txBody>
       </p:sp>
@@ -20025,7 +19725,6 @@
               </a:rPr>
               <a:t>08</a:t>
             </a:r>
-            <a:endParaRPr sz="1200"/>
           </a:p>
         </p:txBody>
       </p:sp>
@@ -20105,7 +19804,6 @@
               </a:rPr>
               <a:t>JSON DUALITY VIEWS</a:t>
             </a:r>
-            <a:endParaRPr sz="1100"/>
           </a:p>
         </p:txBody>
       </p:sp>
@@ -20156,7 +19854,6 @@
               </a:rPr>
               <a:t>Where it can be applied</a:t>
             </a:r>
-            <a:endParaRPr sz="2600"/>
           </a:p>
         </p:txBody>
       </p:sp>
@@ -20207,7 +19904,6 @@
               </a:rPr>
               <a:t>Best fit: a clear aggregate root — one document the API already treats as a unit of work — over tables that already have keys.</a:t>
             </a:r>
-            <a:endParaRPr sz="1400"/>
           </a:p>
         </p:txBody>
       </p:sp>
@@ -20318,7 +20014,6 @@
               </a:rPr>
               <a:t>Commerce</a:t>
             </a:r>
-            <a:endParaRPr sz="1600"/>
           </a:p>
         </p:txBody>
       </p:sp>
@@ -20369,7 +20064,6 @@
               </a:rPr>
               <a:t>Order + line items + shipping. Checkout and admin send one payload; finance still joins tables.</a:t>
             </a:r>
-            <a:endParaRPr sz="1300"/>
           </a:p>
         </p:txBody>
       </p:sp>
@@ -20480,7 +20174,6 @@
               </a:rPr>
               <a:t>CRM / 360</a:t>
             </a:r>
-            <a:endParaRPr sz="1600"/>
           </a:p>
         </p:txBody>
       </p:sp>
@@ -20531,7 +20224,6 @@
               </a:rPr>
               <a:t>Customer + addresses + contacts. Profile UI is a document; warehouse and compliance stay relational.</a:t>
             </a:r>
-            <a:endParaRPr sz="1300"/>
           </a:p>
         </p:txBody>
       </p:sp>
@@ -20642,7 +20334,6 @@
               </a:rPr>
               <a:t>Catalog / PIM</a:t>
             </a:r>
-            <a:endParaRPr sz="1600"/>
           </a:p>
         </p:txBody>
       </p:sp>
@@ -20693,7 +20384,6 @@
               </a:rPr>
               <a:t>Product + variants + attributes + media. Storefront JSON; merchandising and stock stay in tables.</a:t>
             </a:r>
-            <a:endParaRPr sz="1300"/>
           </a:p>
         </p:txBody>
       </p:sp>
@@ -20804,7 +20494,6 @@
               </a:rPr>
               <a:t>SaaS entitlements</a:t>
             </a:r>
-            <a:endParaRPr sz="1600"/>
           </a:p>
         </p:txBody>
       </p:sp>
@@ -20855,7 +20544,6 @@
               </a:rPr>
               <a:t>Account + plans + seats + flags. Portal PUTs one account; billing engines query tables.</a:t>
             </a:r>
-            <a:endParaRPr sz="1300"/>
           </a:p>
         </p:txBody>
       </p:sp>
@@ -20966,7 +20654,6 @@
               </a:rPr>
               <a:t>Content backends</a:t>
             </a:r>
-            <a:endParaRPr sz="1600"/>
           </a:p>
         </p:txBody>
       </p:sp>
@@ -21017,7 +20704,6 @@
               </a:rPr>
               <a:t>Article + authors + tags + revisions. Editors send a document; search uses tables.</a:t>
             </a:r>
-            <a:endParaRPr sz="1300"/>
           </a:p>
         </p:txBody>
       </p:sp>
@@ -21128,7 +20814,6 @@
               </a:rPr>
               <a:t>REST / PWA / mobile</a:t>
             </a:r>
-            <a:endParaRPr sz="1600"/>
           </a:p>
         </p:txBody>
       </p:sp>
@@ -21179,7 +20864,6 @@
               </a:rPr>
               <a:t>MySQL REST Service can expose the view as one collection. Natural fit for HTTP JSON clients.</a:t>
             </a:r>
-            <a:endParaRPr sz="1300"/>
           </a:p>
         </p:txBody>
       </p:sp>
@@ -21257,7 +20941,6 @@
               </a:rPr>
               <a:t>MYSQL 9.7 LTS  |  COMMUNITY SERVER 26.7</a:t>
             </a:r>
-            <a:endParaRPr sz="1000"/>
           </a:p>
         </p:txBody>
       </p:sp>
@@ -21308,7 +20991,6 @@
               </a:rPr>
               <a:t>Duality — applications</a:t>
             </a:r>
-            <a:endParaRPr sz="1000"/>
           </a:p>
         </p:txBody>
       </p:sp>
@@ -21359,7 +21041,6 @@
               </a:rPr>
               <a:t>09</a:t>
             </a:r>
-            <a:endParaRPr sz="1200"/>
           </a:p>
         </p:txBody>
       </p:sp>

</xml_diff>